<commit_message>
deck v2: experiment protocols slide (iteration 26)
</commit_message>
<xml_diff>
--- a/docs/05-summary/management-deck-v2.pptx
+++ b/docs/05-summary/management-deck-v2.pptx
@@ -117,7 +117,7 @@
   <p:extLst>
     <p:ext uri="{521415D9-36F7-43E2-AB2F-B90AF26B5E84}">
       <p14:sectionLst xmlns:p14="http://schemas.microsoft.com/office/powerpoint/2010/main">
-        <p14:section name="Situation" id="{270271be-c0df-9148-a025-f1e1c0165d9b}">
+        <p14:section name="Situation" id="{c488a784-1ae4-b742-22b9-afa48852f3a6}">
           <p14:sldIdLst>
             <p14:sldId id="256"/>
             <p14:sldId id="257"/>
@@ -125,21 +125,21 @@
             <p14:sldId id="259"/>
           </p14:sldIdLst>
         </p14:section>
-        <p14:section name="Findings" id="{42c5e5ce-3ff1-1998-650f-e48f8148f5d1}">
+        <p14:section name="Findings" id="{556b3b11-a721-1944-258a-efba2e7f6676}">
           <p14:sldIdLst>
             <p14:sldId id="260"/>
             <p14:sldId id="261"/>
             <p14:sldId id="262"/>
           </p14:sldIdLst>
         </p14:section>
-        <p14:section name="Quality model" id="{742f1c03-a8d3-14e5-8621-e500bec19601}">
+        <p14:section name="Quality model" id="{6f472f7a-2238-6af2-2a78-d77c7a162b15}">
           <p14:sldIdLst>
             <p14:sldId id="263"/>
             <p14:sldId id="264"/>
             <p14:sldId id="265"/>
           </p14:sldIdLst>
         </p14:section>
-        <p14:section name="Decisions" id="{32b77ddc-d132-f8ea-29f6-12f636e439c8}">
+        <p14:section name="Decisions" id="{f477636d-9ab5-27f2-ddfc-3fb893acd0d9}">
           <p14:sldIdLst>
             <p14:sldId id="266"/>
           </p14:sldIdLst>
@@ -2100,7 +2100,7 @@
           <a:p>
             <a:r>
               <a:rPr lang="en-US" dirty="0"/>
-              <a:t>Success = a difference vs control whose confidence interval excludes no effect, or a clear pre/post change with the control flat.</a:t>
+              <a:t>Protocols: docs/07-quality-model/experiment-protocols-v0.md (D-038). Candidates and matched controls come from data (agg_exp_readiness). A practice spreads only when it beats its control.</a:t>
             </a:r>
             <a:endParaRPr lang="en-US" dirty="0"/>
           </a:p>
@@ -3885,32 +3885,1710 @@
                   <a:schemeClr val="tx1"/>
                 </a:solidFill>
               </a:rPr>
-              <a:t>Five small experiments before any rollout</a:t>
+              <a:t>Five experiments, redesigned so the data can show a result</a:t>
             </a:r>
             <a:endParaRPr lang="en-US" sz="3000" dirty="0"/>
           </a:p>
         </p:txBody>
       </p:sp>
-      <p:sp>
-        <p:nvSpPr>
-          <p:cNvPr id="3" name="num-1"/>
+      <p:graphicFrame>
+        <p:nvGraphicFramePr>
+          <p:cNvPr id="11" name="exp-table"/>
+          <p:cNvGraphicFramePr>
+            <a:graphicFrameLocks noGrp="1"/>
+          </p:cNvGraphicFramePr>
+          <p:nvPr>
+            <p:extLst>
+              <p:ext uri="{D42A27DB-BD31-4B8C-83A1-F6EECF244321}">
+                <p14:modId xmlns:p14="http://schemas.microsoft.com/office/powerpoint/2010/main" val="1579011935"/>
+              </p:ext>
+            </p:extLst>
+          </p:nvPr>
+        </p:nvGraphicFramePr>
+        <p:xfrm>
+          <a:off x="548640" y="1371600"/>
+          <a:ext cx="11064240" cy="914400"/>
+        </p:xfrm>
+        <a:graphic>
+          <a:graphicData uri="http://schemas.openxmlformats.org/drawingml/2006/table">
+            <a:tbl>
+              <a:tblPr/>
+              <a:tblGrid>
+                <a:gridCol w="2377440"/>
+                <a:gridCol w="3291840"/>
+                <a:gridCol w="3840480"/>
+                <a:gridCol w="1554480"/>
+              </a:tblGrid>
+              <a:tr h="548640">
+                <a:tc>
+                  <a:txBody>
+                    <a:bodyPr/>
+                    <a:lstStyle/>
+                    <a:p>
+                      <a:pPr indent="0" marL="0">
+                        <a:buNone/>
+                      </a:pPr>
+                      <a:r>
+                        <a:rPr lang="en-US" sz="1400" b="1" dirty="0">
+                          <a:solidFill>
+                            <a:srgbClr val="FFFFFF"/>
+                          </a:solidFill>
+                          <a:latin typeface="Calibri" pitchFamily="34" charset="0"/>
+                          <a:ea typeface="Calibri" pitchFamily="34" charset="-122"/>
+                          <a:cs typeface="Calibri" pitchFamily="34" charset="-120"/>
+                        </a:rPr>
+                        <a:t>Experiment</a:t>
+                      </a:r>
+                      <a:endParaRPr lang="en-US" sz="1400" dirty="0">
+                        <a:latin typeface="Calibri" charset="0"/>
+                        <a:ea typeface="Calibri" charset="0"/>
+                        <a:cs typeface="Calibri" charset="0"/>
+                      </a:endParaRPr>
+                    </a:p>
+                  </a:txBody>
+                  <a:tcPr marL="91440" marR="91440" marT="45720" marB="45720" anchor="ctr">
+                    <a:lnL w="6350" cap="flat" cmpd="sng" algn="ctr">
+                      <a:solidFill>
+                        <a:srgbClr val="DDE3EA"/>
+                      </a:solidFill>
+                      <a:prstDash val="solid"/>
+                      <a:round/>
+                      <a:headEnd type="none" w="med" len="med"/>
+                      <a:tailEnd type="none" w="med" len="med"/>
+                    </a:lnL>
+                    <a:lnR w="6350" cap="flat" cmpd="sng" algn="ctr">
+                      <a:solidFill>
+                        <a:srgbClr val="DDE3EA"/>
+                      </a:solidFill>
+                      <a:prstDash val="solid"/>
+                      <a:round/>
+                      <a:headEnd type="none" w="med" len="med"/>
+                      <a:tailEnd type="none" w="med" len="med"/>
+                    </a:lnR>
+                    <a:lnT w="6350" cap="flat" cmpd="sng" algn="ctr">
+                      <a:solidFill>
+                        <a:srgbClr val="DDE3EA"/>
+                      </a:solidFill>
+                      <a:prstDash val="solid"/>
+                      <a:round/>
+                      <a:headEnd type="none" w="med" len="med"/>
+                      <a:tailEnd type="none" w="med" len="med"/>
+                    </a:lnT>
+                    <a:lnB w="6350" cap="flat" cmpd="sng" algn="ctr">
+                      <a:solidFill>
+                        <a:srgbClr val="DDE3EA"/>
+                      </a:solidFill>
+                      <a:prstDash val="solid"/>
+                      <a:round/>
+                      <a:headEnd type="none" w="med" len="med"/>
+                      <a:tailEnd type="none" w="med" len="med"/>
+                    </a:lnB>
+                    <a:solidFill>
+                      <a:srgbClr val="1B2A41"/>
+                    </a:solidFill>
+                  </a:tcPr>
+                </a:tc>
+                <a:tc>
+                  <a:txBody>
+                    <a:bodyPr/>
+                    <a:lstStyle/>
+                    <a:p>
+                      <a:pPr indent="0" marL="0">
+                        <a:buNone/>
+                      </a:pPr>
+                      <a:r>
+                        <a:rPr lang="en-US" sz="1400" b="1" dirty="0">
+                          <a:solidFill>
+                            <a:srgbClr val="FFFFFF"/>
+                          </a:solidFill>
+                          <a:latin typeface="Calibri" pitchFamily="34" charset="0"/>
+                          <a:ea typeface="Calibri" pitchFamily="34" charset="-122"/>
+                          <a:cs typeface="Calibri" pitchFamily="34" charset="-120"/>
+                        </a:rPr>
+                        <a:t>Arms</a:t>
+                      </a:r>
+                      <a:endParaRPr lang="en-US" sz="1400" dirty="0">
+                        <a:latin typeface="Calibri" charset="0"/>
+                        <a:ea typeface="Calibri" charset="0"/>
+                        <a:cs typeface="Calibri" charset="0"/>
+                      </a:endParaRPr>
+                    </a:p>
+                  </a:txBody>
+                  <a:tcPr marL="91440" marR="91440" marT="45720" marB="45720" anchor="ctr">
+                    <a:lnL w="6350" cap="flat" cmpd="sng" algn="ctr">
+                      <a:solidFill>
+                        <a:srgbClr val="DDE3EA"/>
+                      </a:solidFill>
+                      <a:prstDash val="solid"/>
+                      <a:round/>
+                      <a:headEnd type="none" w="med" len="med"/>
+                      <a:tailEnd type="none" w="med" len="med"/>
+                    </a:lnL>
+                    <a:lnR w="6350" cap="flat" cmpd="sng" algn="ctr">
+                      <a:solidFill>
+                        <a:srgbClr val="DDE3EA"/>
+                      </a:solidFill>
+                      <a:prstDash val="solid"/>
+                      <a:round/>
+                      <a:headEnd type="none" w="med" len="med"/>
+                      <a:tailEnd type="none" w="med" len="med"/>
+                    </a:lnR>
+                    <a:lnT w="6350" cap="flat" cmpd="sng" algn="ctr">
+                      <a:solidFill>
+                        <a:srgbClr val="DDE3EA"/>
+                      </a:solidFill>
+                      <a:prstDash val="solid"/>
+                      <a:round/>
+                      <a:headEnd type="none" w="med" len="med"/>
+                      <a:tailEnd type="none" w="med" len="med"/>
+                    </a:lnT>
+                    <a:lnB w="6350" cap="flat" cmpd="sng" algn="ctr">
+                      <a:solidFill>
+                        <a:srgbClr val="DDE3EA"/>
+                      </a:solidFill>
+                      <a:prstDash val="solid"/>
+                      <a:round/>
+                      <a:headEnd type="none" w="med" len="med"/>
+                      <a:tailEnd type="none" w="med" len="med"/>
+                    </a:lnB>
+                    <a:solidFill>
+                      <a:srgbClr val="1B2A41"/>
+                    </a:solidFill>
+                  </a:tcPr>
+                </a:tc>
+                <a:tc>
+                  <a:txBody>
+                    <a:bodyPr/>
+                    <a:lstStyle/>
+                    <a:p>
+                      <a:pPr indent="0" marL="0">
+                        <a:buNone/>
+                      </a:pPr>
+                      <a:r>
+                        <a:rPr lang="en-US" sz="1400" b="1" dirty="0">
+                          <a:solidFill>
+                            <a:srgbClr val="FFFFFF"/>
+                          </a:solidFill>
+                          <a:latin typeface="Calibri" pitchFamily="34" charset="0"/>
+                          <a:ea typeface="Calibri" pitchFamily="34" charset="-122"/>
+                          <a:cs typeface="Calibri" pitchFamily="34" charset="-120"/>
+                        </a:rPr>
+                        <a:t>Primary measure</a:t>
+                      </a:r>
+                      <a:endParaRPr lang="en-US" sz="1400" dirty="0">
+                        <a:latin typeface="Calibri" charset="0"/>
+                        <a:ea typeface="Calibri" charset="0"/>
+                        <a:cs typeface="Calibri" charset="0"/>
+                      </a:endParaRPr>
+                    </a:p>
+                  </a:txBody>
+                  <a:tcPr marL="91440" marR="91440" marT="45720" marB="45720" anchor="ctr">
+                    <a:lnL w="6350" cap="flat" cmpd="sng" algn="ctr">
+                      <a:solidFill>
+                        <a:srgbClr val="DDE3EA"/>
+                      </a:solidFill>
+                      <a:prstDash val="solid"/>
+                      <a:round/>
+                      <a:headEnd type="none" w="med" len="med"/>
+                      <a:tailEnd type="none" w="med" len="med"/>
+                    </a:lnL>
+                    <a:lnR w="6350" cap="flat" cmpd="sng" algn="ctr">
+                      <a:solidFill>
+                        <a:srgbClr val="DDE3EA"/>
+                      </a:solidFill>
+                      <a:prstDash val="solid"/>
+                      <a:round/>
+                      <a:headEnd type="none" w="med" len="med"/>
+                      <a:tailEnd type="none" w="med" len="med"/>
+                    </a:lnR>
+                    <a:lnT w="6350" cap="flat" cmpd="sng" algn="ctr">
+                      <a:solidFill>
+                        <a:srgbClr val="DDE3EA"/>
+                      </a:solidFill>
+                      <a:prstDash val="solid"/>
+                      <a:round/>
+                      <a:headEnd type="none" w="med" len="med"/>
+                      <a:tailEnd type="none" w="med" len="med"/>
+                    </a:lnT>
+                    <a:lnB w="6350" cap="flat" cmpd="sng" algn="ctr">
+                      <a:solidFill>
+                        <a:srgbClr val="DDE3EA"/>
+                      </a:solidFill>
+                      <a:prstDash val="solid"/>
+                      <a:round/>
+                      <a:headEnd type="none" w="med" len="med"/>
+                      <a:tailEnd type="none" w="med" len="med"/>
+                    </a:lnB>
+                    <a:solidFill>
+                      <a:srgbClr val="1B2A41"/>
+                    </a:solidFill>
+                  </a:tcPr>
+                </a:tc>
+                <a:tc>
+                  <a:txBody>
+                    <a:bodyPr/>
+                    <a:lstStyle/>
+                    <a:p>
+                      <a:pPr indent="0" marL="0">
+                        <a:buNone/>
+                      </a:pPr>
+                      <a:r>
+                        <a:rPr lang="en-US" sz="1400" b="1" dirty="0">
+                          <a:solidFill>
+                            <a:srgbClr val="FFFFFF"/>
+                          </a:solidFill>
+                          <a:latin typeface="Calibri" pitchFamily="34" charset="0"/>
+                          <a:ea typeface="Calibri" pitchFamily="34" charset="-122"/>
+                          <a:cs typeface="Calibri" pitchFamily="34" charset="-120"/>
+                        </a:rPr>
+                        <a:t>Duration</a:t>
+                      </a:r>
+                      <a:endParaRPr lang="en-US" sz="1400" dirty="0">
+                        <a:latin typeface="Calibri" charset="0"/>
+                        <a:ea typeface="Calibri" charset="0"/>
+                        <a:cs typeface="Calibri" charset="0"/>
+                      </a:endParaRPr>
+                    </a:p>
+                  </a:txBody>
+                  <a:tcPr marL="91440" marR="91440" marT="45720" marB="45720" anchor="ctr">
+                    <a:lnL w="6350" cap="flat" cmpd="sng" algn="ctr">
+                      <a:solidFill>
+                        <a:srgbClr val="DDE3EA"/>
+                      </a:solidFill>
+                      <a:prstDash val="solid"/>
+                      <a:round/>
+                      <a:headEnd type="none" w="med" len="med"/>
+                      <a:tailEnd type="none" w="med" len="med"/>
+                    </a:lnL>
+                    <a:lnR w="6350" cap="flat" cmpd="sng" algn="ctr">
+                      <a:solidFill>
+                        <a:srgbClr val="DDE3EA"/>
+                      </a:solidFill>
+                      <a:prstDash val="solid"/>
+                      <a:round/>
+                      <a:headEnd type="none" w="med" len="med"/>
+                      <a:tailEnd type="none" w="med" len="med"/>
+                    </a:lnR>
+                    <a:lnT w="6350" cap="flat" cmpd="sng" algn="ctr">
+                      <a:solidFill>
+                        <a:srgbClr val="DDE3EA"/>
+                      </a:solidFill>
+                      <a:prstDash val="solid"/>
+                      <a:round/>
+                      <a:headEnd type="none" w="med" len="med"/>
+                      <a:tailEnd type="none" w="med" len="med"/>
+                    </a:lnT>
+                    <a:lnB w="6350" cap="flat" cmpd="sng" algn="ctr">
+                      <a:solidFill>
+                        <a:srgbClr val="DDE3EA"/>
+                      </a:solidFill>
+                      <a:prstDash val="solid"/>
+                      <a:round/>
+                      <a:headEnd type="none" w="med" len="med"/>
+                      <a:tailEnd type="none" w="med" len="med"/>
+                    </a:lnB>
+                    <a:solidFill>
+                      <a:srgbClr val="1B2A41"/>
+                    </a:solidFill>
+                  </a:tcPr>
+                </a:tc>
+              </a:tr>
+              <a:tr h="548640">
+                <a:tc>
+                  <a:txBody>
+                    <a:bodyPr/>
+                    <a:lstStyle/>
+                    <a:p>
+                      <a:pPr indent="0" marL="0">
+                        <a:buNone/>
+                      </a:pPr>
+                      <a:r>
+                        <a:rPr lang="en-US" sz="1400" b="1" dirty="0">
+                          <a:solidFill>
+                            <a:srgbClr val="1B2A41"/>
+                          </a:solidFill>
+                          <a:latin typeface="Calibri" pitchFamily="34" charset="0"/>
+                          <a:ea typeface="Calibri" pitchFamily="34" charset="-122"/>
+                          <a:cs typeface="Calibri" pitchFamily="34" charset="-120"/>
+                        </a:rPr>
+                        <a:t>X1 Intake fields</a:t>
+                      </a:r>
+                      <a:endParaRPr lang="en-US" sz="1400" dirty="0">
+                        <a:latin typeface="Calibri" charset="0"/>
+                        <a:ea typeface="Calibri" charset="0"/>
+                        <a:cs typeface="Calibri" charset="0"/>
+                      </a:endParaRPr>
+                    </a:p>
+                  </a:txBody>
+                  <a:tcPr marL="91440" marR="91440" marT="45720" marB="45720" anchor="ctr">
+                    <a:lnL w="6350" cap="flat" cmpd="sng" algn="ctr">
+                      <a:solidFill>
+                        <a:srgbClr val="DDE3EA"/>
+                      </a:solidFill>
+                      <a:prstDash val="solid"/>
+                      <a:round/>
+                      <a:headEnd type="none" w="med" len="med"/>
+                      <a:tailEnd type="none" w="med" len="med"/>
+                    </a:lnL>
+                    <a:lnR w="6350" cap="flat" cmpd="sng" algn="ctr">
+                      <a:solidFill>
+                        <a:srgbClr val="DDE3EA"/>
+                      </a:solidFill>
+                      <a:prstDash val="solid"/>
+                      <a:round/>
+                      <a:headEnd type="none" w="med" len="med"/>
+                      <a:tailEnd type="none" w="med" len="med"/>
+                    </a:lnR>
+                    <a:lnT w="6350" cap="flat" cmpd="sng" algn="ctr">
+                      <a:solidFill>
+                        <a:srgbClr val="DDE3EA"/>
+                      </a:solidFill>
+                      <a:prstDash val="solid"/>
+                      <a:round/>
+                      <a:headEnd type="none" w="med" len="med"/>
+                      <a:tailEnd type="none" w="med" len="med"/>
+                    </a:lnT>
+                    <a:lnB w="6350" cap="flat" cmpd="sng" algn="ctr">
+                      <a:solidFill>
+                        <a:srgbClr val="DDE3EA"/>
+                      </a:solidFill>
+                      <a:prstDash val="solid"/>
+                      <a:round/>
+                      <a:headEnd type="none" w="med" len="med"/>
+                      <a:tailEnd type="none" w="med" len="med"/>
+                    </a:lnB>
+                    <a:solidFill>
+                      <a:srgbClr val="EEF2F6"/>
+                    </a:solidFill>
+                  </a:tcPr>
+                </a:tc>
+                <a:tc>
+                  <a:txBody>
+                    <a:bodyPr/>
+                    <a:lstStyle/>
+                    <a:p>
+                      <a:pPr indent="0" marL="0">
+                        <a:buNone/>
+                      </a:pPr>
+                      <a:r>
+                        <a:rPr lang="en-US" sz="1400" dirty="0">
+                          <a:solidFill>
+                            <a:srgbClr val="1B2A41"/>
+                          </a:solidFill>
+                          <a:latin typeface="Calibri" pitchFamily="34" charset="0"/>
+                          <a:ea typeface="Calibri" pitchFamily="34" charset="-122"/>
+                          <a:cs typeface="Calibri" pitchFamily="34" charset="-120"/>
+                        </a:rPr>
+                        <a:t>3 teams (one per type) vs 3 controls</a:t>
+                      </a:r>
+                      <a:endParaRPr lang="en-US" sz="1400" dirty="0">
+                        <a:latin typeface="Calibri" charset="0"/>
+                        <a:ea typeface="Calibri" charset="0"/>
+                        <a:cs typeface="Calibri" charset="0"/>
+                      </a:endParaRPr>
+                    </a:p>
+                  </a:txBody>
+                  <a:tcPr marL="91440" marR="91440" marT="45720" marB="45720" anchor="ctr">
+                    <a:lnL w="6350" cap="flat" cmpd="sng" algn="ctr">
+                      <a:solidFill>
+                        <a:srgbClr val="DDE3EA"/>
+                      </a:solidFill>
+                      <a:prstDash val="solid"/>
+                      <a:round/>
+                      <a:headEnd type="none" w="med" len="med"/>
+                      <a:tailEnd type="none" w="med" len="med"/>
+                    </a:lnL>
+                    <a:lnR w="6350" cap="flat" cmpd="sng" algn="ctr">
+                      <a:solidFill>
+                        <a:srgbClr val="DDE3EA"/>
+                      </a:solidFill>
+                      <a:prstDash val="solid"/>
+                      <a:round/>
+                      <a:headEnd type="none" w="med" len="med"/>
+                      <a:tailEnd type="none" w="med" len="med"/>
+                    </a:lnR>
+                    <a:lnT w="6350" cap="flat" cmpd="sng" algn="ctr">
+                      <a:solidFill>
+                        <a:srgbClr val="DDE3EA"/>
+                      </a:solidFill>
+                      <a:prstDash val="solid"/>
+                      <a:round/>
+                      <a:headEnd type="none" w="med" len="med"/>
+                      <a:tailEnd type="none" w="med" len="med"/>
+                    </a:lnT>
+                    <a:lnB w="6350" cap="flat" cmpd="sng" algn="ctr">
+                      <a:solidFill>
+                        <a:srgbClr val="DDE3EA"/>
+                      </a:solidFill>
+                      <a:prstDash val="solid"/>
+                      <a:round/>
+                      <a:headEnd type="none" w="med" len="med"/>
+                      <a:tailEnd type="none" w="med" len="med"/>
+                    </a:lnB>
+                    <a:solidFill>
+                      <a:srgbClr val="EEF2F6"/>
+                    </a:solidFill>
+                  </a:tcPr>
+                </a:tc>
+                <a:tc>
+                  <a:txBody>
+                    <a:bodyPr/>
+                    <a:lstStyle/>
+                    <a:p>
+                      <a:pPr indent="0" marL="0">
+                        <a:buNone/>
+                      </a:pPr>
+                      <a:r>
+                        <a:rPr lang="en-US" sz="1400" dirty="0">
+                          <a:solidFill>
+                            <a:srgbClr val="1B2A41"/>
+                          </a:solidFill>
+                          <a:latin typeface="Calibri" pitchFamily="34" charset="0"/>
+                          <a:ea typeface="Calibri" pitchFamily="34" charset="-122"/>
+                          <a:cs typeface="Calibri" pitchFamily="34" charset="-120"/>
+                        </a:rPr>
+                        <a:t>Bugs with cause and detected-by (15% today)</a:t>
+                      </a:r>
+                      <a:endParaRPr lang="en-US" sz="1400" dirty="0">
+                        <a:latin typeface="Calibri" charset="0"/>
+                        <a:ea typeface="Calibri" charset="0"/>
+                        <a:cs typeface="Calibri" charset="0"/>
+                      </a:endParaRPr>
+                    </a:p>
+                  </a:txBody>
+                  <a:tcPr marL="91440" marR="91440" marT="45720" marB="45720" anchor="ctr">
+                    <a:lnL w="6350" cap="flat" cmpd="sng" algn="ctr">
+                      <a:solidFill>
+                        <a:srgbClr val="DDE3EA"/>
+                      </a:solidFill>
+                      <a:prstDash val="solid"/>
+                      <a:round/>
+                      <a:headEnd type="none" w="med" len="med"/>
+                      <a:tailEnd type="none" w="med" len="med"/>
+                    </a:lnL>
+                    <a:lnR w="6350" cap="flat" cmpd="sng" algn="ctr">
+                      <a:solidFill>
+                        <a:srgbClr val="DDE3EA"/>
+                      </a:solidFill>
+                      <a:prstDash val="solid"/>
+                      <a:round/>
+                      <a:headEnd type="none" w="med" len="med"/>
+                      <a:tailEnd type="none" w="med" len="med"/>
+                    </a:lnR>
+                    <a:lnT w="6350" cap="flat" cmpd="sng" algn="ctr">
+                      <a:solidFill>
+                        <a:srgbClr val="DDE3EA"/>
+                      </a:solidFill>
+                      <a:prstDash val="solid"/>
+                      <a:round/>
+                      <a:headEnd type="none" w="med" len="med"/>
+                      <a:tailEnd type="none" w="med" len="med"/>
+                    </a:lnT>
+                    <a:lnB w="6350" cap="flat" cmpd="sng" algn="ctr">
+                      <a:solidFill>
+                        <a:srgbClr val="DDE3EA"/>
+                      </a:solidFill>
+                      <a:prstDash val="solid"/>
+                      <a:round/>
+                      <a:headEnd type="none" w="med" len="med"/>
+                      <a:tailEnd type="none" w="med" len="med"/>
+                    </a:lnB>
+                    <a:solidFill>
+                      <a:srgbClr val="EEF2F6"/>
+                    </a:solidFill>
+                  </a:tcPr>
+                </a:tc>
+                <a:tc>
+                  <a:txBody>
+                    <a:bodyPr/>
+                    <a:lstStyle/>
+                    <a:p>
+                      <a:pPr indent="0" marL="0">
+                        <a:buNone/>
+                      </a:pPr>
+                      <a:r>
+                        <a:rPr lang="en-US" sz="1400" dirty="0">
+                          <a:solidFill>
+                            <a:srgbClr val="1B2A41"/>
+                          </a:solidFill>
+                          <a:latin typeface="Calibri" pitchFamily="34" charset="0"/>
+                          <a:ea typeface="Calibri" pitchFamily="34" charset="-122"/>
+                          <a:cs typeface="Calibri" pitchFamily="34" charset="-120"/>
+                        </a:rPr>
+                        <a:t>1 quarter</a:t>
+                      </a:r>
+                      <a:endParaRPr lang="en-US" sz="1400" dirty="0">
+                        <a:latin typeface="Calibri" charset="0"/>
+                        <a:ea typeface="Calibri" charset="0"/>
+                        <a:cs typeface="Calibri" charset="0"/>
+                      </a:endParaRPr>
+                    </a:p>
+                  </a:txBody>
+                  <a:tcPr marL="91440" marR="91440" marT="45720" marB="45720" anchor="ctr">
+                    <a:lnL w="6350" cap="flat" cmpd="sng" algn="ctr">
+                      <a:solidFill>
+                        <a:srgbClr val="DDE3EA"/>
+                      </a:solidFill>
+                      <a:prstDash val="solid"/>
+                      <a:round/>
+                      <a:headEnd type="none" w="med" len="med"/>
+                      <a:tailEnd type="none" w="med" len="med"/>
+                    </a:lnL>
+                    <a:lnR w="6350" cap="flat" cmpd="sng" algn="ctr">
+                      <a:solidFill>
+                        <a:srgbClr val="DDE3EA"/>
+                      </a:solidFill>
+                      <a:prstDash val="solid"/>
+                      <a:round/>
+                      <a:headEnd type="none" w="med" len="med"/>
+                      <a:tailEnd type="none" w="med" len="med"/>
+                    </a:lnR>
+                    <a:lnT w="6350" cap="flat" cmpd="sng" algn="ctr">
+                      <a:solidFill>
+                        <a:srgbClr val="DDE3EA"/>
+                      </a:solidFill>
+                      <a:prstDash val="solid"/>
+                      <a:round/>
+                      <a:headEnd type="none" w="med" len="med"/>
+                      <a:tailEnd type="none" w="med" len="med"/>
+                    </a:lnT>
+                    <a:lnB w="6350" cap="flat" cmpd="sng" algn="ctr">
+                      <a:solidFill>
+                        <a:srgbClr val="DDE3EA"/>
+                      </a:solidFill>
+                      <a:prstDash val="solid"/>
+                      <a:round/>
+                      <a:headEnd type="none" w="med" len="med"/>
+                      <a:tailEnd type="none" w="med" len="med"/>
+                    </a:lnB>
+                    <a:solidFill>
+                      <a:srgbClr val="EEF2F6"/>
+                    </a:solidFill>
+                  </a:tcPr>
+                </a:tc>
+              </a:tr>
+              <a:tr h="548640">
+                <a:tc>
+                  <a:txBody>
+                    <a:bodyPr/>
+                    <a:lstStyle/>
+                    <a:p>
+                      <a:pPr indent="0" marL="0">
+                        <a:buNone/>
+                      </a:pPr>
+                      <a:r>
+                        <a:rPr lang="en-US" sz="1400" b="1" dirty="0">
+                          <a:solidFill>
+                            <a:srgbClr val="1B2A41"/>
+                          </a:solidFill>
+                          <a:latin typeface="Calibri" pitchFamily="34" charset="0"/>
+                          <a:ea typeface="Calibri" pitchFamily="34" charset="-122"/>
+                          <a:cs typeface="Calibri" pitchFamily="34" charset="-120"/>
+                        </a:rPr>
+                        <a:t>X2 Detection</a:t>
+                      </a:r>
+                      <a:endParaRPr lang="en-US" sz="1400" dirty="0">
+                        <a:latin typeface="Calibri" charset="0"/>
+                        <a:ea typeface="Calibri" charset="0"/>
+                        <a:cs typeface="Calibri" charset="0"/>
+                      </a:endParaRPr>
+                    </a:p>
+                  </a:txBody>
+                  <a:tcPr marL="91440" marR="91440" marT="45720" marB="45720" anchor="ctr">
+                    <a:lnL w="6350" cap="flat" cmpd="sng" algn="ctr">
+                      <a:solidFill>
+                        <a:srgbClr val="DDE3EA"/>
+                      </a:solidFill>
+                      <a:prstDash val="solid"/>
+                      <a:round/>
+                      <a:headEnd type="none" w="med" len="med"/>
+                      <a:tailEnd type="none" w="med" len="med"/>
+                    </a:lnL>
+                    <a:lnR w="6350" cap="flat" cmpd="sng" algn="ctr">
+                      <a:solidFill>
+                        <a:srgbClr val="DDE3EA"/>
+                      </a:solidFill>
+                      <a:prstDash val="solid"/>
+                      <a:round/>
+                      <a:headEnd type="none" w="med" len="med"/>
+                      <a:tailEnd type="none" w="med" len="med"/>
+                    </a:lnR>
+                    <a:lnT w="6350" cap="flat" cmpd="sng" algn="ctr">
+                      <a:solidFill>
+                        <a:srgbClr val="DDE3EA"/>
+                      </a:solidFill>
+                      <a:prstDash val="solid"/>
+                      <a:round/>
+                      <a:headEnd type="none" w="med" len="med"/>
+                      <a:tailEnd type="none" w="med" len="med"/>
+                    </a:lnT>
+                    <a:lnB w="6350" cap="flat" cmpd="sng" algn="ctr">
+                      <a:solidFill>
+                        <a:srgbClr val="DDE3EA"/>
+                      </a:solidFill>
+                      <a:prstDash val="solid"/>
+                      <a:round/>
+                      <a:headEnd type="none" w="med" len="med"/>
+                      <a:tailEnd type="none" w="med" len="med"/>
+                    </a:lnB>
+                    <a:solidFill>
+                      <a:srgbClr val="FFFFFF"/>
+                    </a:solidFill>
+                  </a:tcPr>
+                </a:tc>
+                <a:tc>
+                  <a:txBody>
+                    <a:bodyPr/>
+                    <a:lstStyle/>
+                    <a:p>
+                      <a:pPr indent="0" marL="0">
+                        <a:buNone/>
+                      </a:pPr>
+                      <a:r>
+                        <a:rPr lang="en-US" sz="1400" dirty="0">
+                          <a:solidFill>
+                            <a:srgbClr val="1B2A41"/>
+                          </a:solidFill>
+                          <a:latin typeface="Calibri" pitchFamily="34" charset="0"/>
+                          <a:ea typeface="Calibri" pitchFamily="34" charset="-122"/>
+                          <a:cs typeface="Calibri" pitchFamily="34" charset="-120"/>
+                        </a:rPr>
+                        <a:t>1 high-impact team, shadow mode</a:t>
+                      </a:r>
+                      <a:endParaRPr lang="en-US" sz="1400" dirty="0">
+                        <a:latin typeface="Calibri" charset="0"/>
+                        <a:ea typeface="Calibri" charset="0"/>
+                        <a:cs typeface="Calibri" charset="0"/>
+                      </a:endParaRPr>
+                    </a:p>
+                  </a:txBody>
+                  <a:tcPr marL="91440" marR="91440" marT="45720" marB="45720" anchor="ctr">
+                    <a:lnL w="6350" cap="flat" cmpd="sng" algn="ctr">
+                      <a:solidFill>
+                        <a:srgbClr val="DDE3EA"/>
+                      </a:solidFill>
+                      <a:prstDash val="solid"/>
+                      <a:round/>
+                      <a:headEnd type="none" w="med" len="med"/>
+                      <a:tailEnd type="none" w="med" len="med"/>
+                    </a:lnL>
+                    <a:lnR w="6350" cap="flat" cmpd="sng" algn="ctr">
+                      <a:solidFill>
+                        <a:srgbClr val="DDE3EA"/>
+                      </a:solidFill>
+                      <a:prstDash val="solid"/>
+                      <a:round/>
+                      <a:headEnd type="none" w="med" len="med"/>
+                      <a:tailEnd type="none" w="med" len="med"/>
+                    </a:lnR>
+                    <a:lnT w="6350" cap="flat" cmpd="sng" algn="ctr">
+                      <a:solidFill>
+                        <a:srgbClr val="DDE3EA"/>
+                      </a:solidFill>
+                      <a:prstDash val="solid"/>
+                      <a:round/>
+                      <a:headEnd type="none" w="med" len="med"/>
+                      <a:tailEnd type="none" w="med" len="med"/>
+                    </a:lnT>
+                    <a:lnB w="6350" cap="flat" cmpd="sng" algn="ctr">
+                      <a:solidFill>
+                        <a:srgbClr val="DDE3EA"/>
+                      </a:solidFill>
+                      <a:prstDash val="solid"/>
+                      <a:round/>
+                      <a:headEnd type="none" w="med" len="med"/>
+                      <a:tailEnd type="none" w="med" len="med"/>
+                    </a:lnB>
+                    <a:solidFill>
+                      <a:srgbClr val="FFFFFF"/>
+                    </a:solidFill>
+                  </a:tcPr>
+                </a:tc>
+                <a:tc>
+                  <a:txBody>
+                    <a:bodyPr/>
+                    <a:lstStyle/>
+                    <a:p>
+                      <a:pPr indent="0" marL="0">
+                        <a:buNone/>
+                      </a:pPr>
+                      <a:r>
+                        <a:rPr lang="en-US" sz="1400" dirty="0">
+                          <a:solidFill>
+                            <a:srgbClr val="1B2A41"/>
+                          </a:solidFill>
+                          <a:latin typeface="Calibri" pitchFamily="34" charset="0"/>
+                          <a:ea typeface="Calibri" pitchFamily="34" charset="-122"/>
+                          <a:cs typeface="Calibri" pitchFamily="34" charset="-120"/>
+                        </a:rPr>
+                        <a:t>Alerts before a customer case; lead time</a:t>
+                      </a:r>
+                      <a:endParaRPr lang="en-US" sz="1400" dirty="0">
+                        <a:latin typeface="Calibri" charset="0"/>
+                        <a:ea typeface="Calibri" charset="0"/>
+                        <a:cs typeface="Calibri" charset="0"/>
+                      </a:endParaRPr>
+                    </a:p>
+                  </a:txBody>
+                  <a:tcPr marL="91440" marR="91440" marT="45720" marB="45720" anchor="ctr">
+                    <a:lnL w="6350" cap="flat" cmpd="sng" algn="ctr">
+                      <a:solidFill>
+                        <a:srgbClr val="DDE3EA"/>
+                      </a:solidFill>
+                      <a:prstDash val="solid"/>
+                      <a:round/>
+                      <a:headEnd type="none" w="med" len="med"/>
+                      <a:tailEnd type="none" w="med" len="med"/>
+                    </a:lnL>
+                    <a:lnR w="6350" cap="flat" cmpd="sng" algn="ctr">
+                      <a:solidFill>
+                        <a:srgbClr val="DDE3EA"/>
+                      </a:solidFill>
+                      <a:prstDash val="solid"/>
+                      <a:round/>
+                      <a:headEnd type="none" w="med" len="med"/>
+                      <a:tailEnd type="none" w="med" len="med"/>
+                    </a:lnR>
+                    <a:lnT w="6350" cap="flat" cmpd="sng" algn="ctr">
+                      <a:solidFill>
+                        <a:srgbClr val="DDE3EA"/>
+                      </a:solidFill>
+                      <a:prstDash val="solid"/>
+                      <a:round/>
+                      <a:headEnd type="none" w="med" len="med"/>
+                      <a:tailEnd type="none" w="med" len="med"/>
+                    </a:lnT>
+                    <a:lnB w="6350" cap="flat" cmpd="sng" algn="ctr">
+                      <a:solidFill>
+                        <a:srgbClr val="DDE3EA"/>
+                      </a:solidFill>
+                      <a:prstDash val="solid"/>
+                      <a:round/>
+                      <a:headEnd type="none" w="med" len="med"/>
+                      <a:tailEnd type="none" w="med" len="med"/>
+                    </a:lnB>
+                    <a:solidFill>
+                      <a:srgbClr val="FFFFFF"/>
+                    </a:solidFill>
+                  </a:tcPr>
+                </a:tc>
+                <a:tc>
+                  <a:txBody>
+                    <a:bodyPr/>
+                    <a:lstStyle/>
+                    <a:p>
+                      <a:pPr indent="0" marL="0">
+                        <a:buNone/>
+                      </a:pPr>
+                      <a:r>
+                        <a:rPr lang="en-US" sz="1400" dirty="0">
+                          <a:solidFill>
+                            <a:srgbClr val="1B2A41"/>
+                          </a:solidFill>
+                          <a:latin typeface="Calibri" pitchFamily="34" charset="0"/>
+                          <a:ea typeface="Calibri" pitchFamily="34" charset="-122"/>
+                          <a:cs typeface="Calibri" pitchFamily="34" charset="-120"/>
+                        </a:rPr>
+                        <a:t>6 weeks + 1 quarter</a:t>
+                      </a:r>
+                      <a:endParaRPr lang="en-US" sz="1400" dirty="0">
+                        <a:latin typeface="Calibri" charset="0"/>
+                        <a:ea typeface="Calibri" charset="0"/>
+                        <a:cs typeface="Calibri" charset="0"/>
+                      </a:endParaRPr>
+                    </a:p>
+                  </a:txBody>
+                  <a:tcPr marL="91440" marR="91440" marT="45720" marB="45720" anchor="ctr">
+                    <a:lnL w="6350" cap="flat" cmpd="sng" algn="ctr">
+                      <a:solidFill>
+                        <a:srgbClr val="DDE3EA"/>
+                      </a:solidFill>
+                      <a:prstDash val="solid"/>
+                      <a:round/>
+                      <a:headEnd type="none" w="med" len="med"/>
+                      <a:tailEnd type="none" w="med" len="med"/>
+                    </a:lnL>
+                    <a:lnR w="6350" cap="flat" cmpd="sng" algn="ctr">
+                      <a:solidFill>
+                        <a:srgbClr val="DDE3EA"/>
+                      </a:solidFill>
+                      <a:prstDash val="solid"/>
+                      <a:round/>
+                      <a:headEnd type="none" w="med" len="med"/>
+                      <a:tailEnd type="none" w="med" len="med"/>
+                    </a:lnR>
+                    <a:lnT w="6350" cap="flat" cmpd="sng" algn="ctr">
+                      <a:solidFill>
+                        <a:srgbClr val="DDE3EA"/>
+                      </a:solidFill>
+                      <a:prstDash val="solid"/>
+                      <a:round/>
+                      <a:headEnd type="none" w="med" len="med"/>
+                      <a:tailEnd type="none" w="med" len="med"/>
+                    </a:lnT>
+                    <a:lnB w="6350" cap="flat" cmpd="sng" algn="ctr">
+                      <a:solidFill>
+                        <a:srgbClr val="DDE3EA"/>
+                      </a:solidFill>
+                      <a:prstDash val="solid"/>
+                      <a:round/>
+                      <a:headEnd type="none" w="med" len="med"/>
+                      <a:tailEnd type="none" w="med" len="med"/>
+                    </a:lnB>
+                    <a:solidFill>
+                      <a:srgbClr val="FFFFFF"/>
+                    </a:solidFill>
+                  </a:tcPr>
+                </a:tc>
+              </a:tr>
+              <a:tr h="548640">
+                <a:tc>
+                  <a:txBody>
+                    <a:bodyPr/>
+                    <a:lstStyle/>
+                    <a:p>
+                      <a:pPr indent="0" marL="0">
+                        <a:buNone/>
+                      </a:pPr>
+                      <a:r>
+                        <a:rPr lang="en-US" sz="1400" b="1" dirty="0">
+                          <a:solidFill>
+                            <a:srgbClr val="1B2A41"/>
+                          </a:solidFill>
+                          <a:latin typeface="Calibri" pitchFamily="34" charset="0"/>
+                          <a:ea typeface="Calibri" pitchFamily="34" charset="-122"/>
+                          <a:cs typeface="Calibri" pitchFamily="34" charset="-120"/>
+                        </a:rPr>
+                        <a:t>X3 Review by size</a:t>
+                      </a:r>
+                      <a:endParaRPr lang="en-US" sz="1400" dirty="0">
+                        <a:latin typeface="Calibri" charset="0"/>
+                        <a:ea typeface="Calibri" charset="0"/>
+                        <a:cs typeface="Calibri" charset="0"/>
+                      </a:endParaRPr>
+                    </a:p>
+                  </a:txBody>
+                  <a:tcPr marL="91440" marR="91440" marT="45720" marB="45720" anchor="ctr">
+                    <a:lnL w="6350" cap="flat" cmpd="sng" algn="ctr">
+                      <a:solidFill>
+                        <a:srgbClr val="DDE3EA"/>
+                      </a:solidFill>
+                      <a:prstDash val="solid"/>
+                      <a:round/>
+                      <a:headEnd type="none" w="med" len="med"/>
+                      <a:tailEnd type="none" w="med" len="med"/>
+                    </a:lnL>
+                    <a:lnR w="6350" cap="flat" cmpd="sng" algn="ctr">
+                      <a:solidFill>
+                        <a:srgbClr val="DDE3EA"/>
+                      </a:solidFill>
+                      <a:prstDash val="solid"/>
+                      <a:round/>
+                      <a:headEnd type="none" w="med" len="med"/>
+                      <a:tailEnd type="none" w="med" len="med"/>
+                    </a:lnR>
+                    <a:lnT w="6350" cap="flat" cmpd="sng" algn="ctr">
+                      <a:solidFill>
+                        <a:srgbClr val="DDE3EA"/>
+                      </a:solidFill>
+                      <a:prstDash val="solid"/>
+                      <a:round/>
+                      <a:headEnd type="none" w="med" len="med"/>
+                      <a:tailEnd type="none" w="med" len="med"/>
+                    </a:lnT>
+                    <a:lnB w="6350" cap="flat" cmpd="sng" algn="ctr">
+                      <a:solidFill>
+                        <a:srgbClr val="DDE3EA"/>
+                      </a:solidFill>
+                      <a:prstDash val="solid"/>
+                      <a:round/>
+                      <a:headEnd type="none" w="med" len="med"/>
+                      <a:tailEnd type="none" w="med" len="med"/>
+                    </a:lnB>
+                    <a:solidFill>
+                      <a:srgbClr val="EEF2F6"/>
+                    </a:solidFill>
+                  </a:tcPr>
+                </a:tc>
+                <a:tc>
+                  <a:txBody>
+                    <a:bodyPr/>
+                    <a:lstStyle/>
+                    <a:p>
+                      <a:pPr indent="0" marL="0">
+                        <a:buNone/>
+                      </a:pPr>
+                      <a:r>
+                        <a:rPr lang="en-US" sz="1400" dirty="0">
+                          <a:solidFill>
+                            <a:srgbClr val="1B2A41"/>
+                          </a:solidFill>
+                          <a:latin typeface="Calibri" pitchFamily="34" charset="0"/>
+                          <a:ea typeface="Calibri" pitchFamily="34" charset="-122"/>
+                          <a:cs typeface="Calibri" pitchFamily="34" charset="-120"/>
+                        </a:rPr>
+                        <a:t>All teams with hotspot PRs, 2-step start</a:t>
+                      </a:r>
+                      <a:endParaRPr lang="en-US" sz="1400" dirty="0">
+                        <a:latin typeface="Calibri" charset="0"/>
+                        <a:ea typeface="Calibri" charset="0"/>
+                        <a:cs typeface="Calibri" charset="0"/>
+                      </a:endParaRPr>
+                    </a:p>
+                  </a:txBody>
+                  <a:tcPr marL="91440" marR="91440" marT="45720" marB="45720" anchor="ctr">
+                    <a:lnL w="6350" cap="flat" cmpd="sng" algn="ctr">
+                      <a:solidFill>
+                        <a:srgbClr val="DDE3EA"/>
+                      </a:solidFill>
+                      <a:prstDash val="solid"/>
+                      <a:round/>
+                      <a:headEnd type="none" w="med" len="med"/>
+                      <a:tailEnd type="none" w="med" len="med"/>
+                    </a:lnL>
+                    <a:lnR w="6350" cap="flat" cmpd="sng" algn="ctr">
+                      <a:solidFill>
+                        <a:srgbClr val="DDE3EA"/>
+                      </a:solidFill>
+                      <a:prstDash val="solid"/>
+                      <a:round/>
+                      <a:headEnd type="none" w="med" len="med"/>
+                      <a:tailEnd type="none" w="med" len="med"/>
+                    </a:lnR>
+                    <a:lnT w="6350" cap="flat" cmpd="sng" algn="ctr">
+                      <a:solidFill>
+                        <a:srgbClr val="DDE3EA"/>
+                      </a:solidFill>
+                      <a:prstDash val="solid"/>
+                      <a:round/>
+                      <a:headEnd type="none" w="med" len="med"/>
+                      <a:tailEnd type="none" w="med" len="med"/>
+                    </a:lnT>
+                    <a:lnB w="6350" cap="flat" cmpd="sng" algn="ctr">
+                      <a:solidFill>
+                        <a:srgbClr val="DDE3EA"/>
+                      </a:solidFill>
+                      <a:prstDash val="solid"/>
+                      <a:round/>
+                      <a:headEnd type="none" w="med" len="med"/>
+                      <a:tailEnd type="none" w="med" len="med"/>
+                    </a:lnB>
+                    <a:solidFill>
+                      <a:srgbClr val="EEF2F6"/>
+                    </a:solidFill>
+                  </a:tcPr>
+                </a:tc>
+                <a:tc>
+                  <a:txBody>
+                    <a:bodyPr/>
+                    <a:lstStyle/>
+                    <a:p>
+                      <a:pPr indent="0" marL="0">
+                        <a:buNone/>
+                      </a:pPr>
+                      <a:r>
+                        <a:rPr lang="en-US" sz="1400" dirty="0">
+                          <a:solidFill>
+                            <a:srgbClr val="1B2A41"/>
+                          </a:solidFill>
+                          <a:latin typeface="Calibri" pitchFamily="34" charset="0"/>
+                          <a:ea typeface="Calibri" pitchFamily="34" charset="-122"/>
+                          <a:cs typeface="Calibri" pitchFamily="34" charset="-120"/>
+                        </a:rPr>
+                        <a:t>Follow-up fixes per hotspot PR (about 70%)</a:t>
+                      </a:r>
+                      <a:endParaRPr lang="en-US" sz="1400" dirty="0">
+                        <a:latin typeface="Calibri" charset="0"/>
+                        <a:ea typeface="Calibri" charset="0"/>
+                        <a:cs typeface="Calibri" charset="0"/>
+                      </a:endParaRPr>
+                    </a:p>
+                  </a:txBody>
+                  <a:tcPr marL="91440" marR="91440" marT="45720" marB="45720" anchor="ctr">
+                    <a:lnL w="6350" cap="flat" cmpd="sng" algn="ctr">
+                      <a:solidFill>
+                        <a:srgbClr val="DDE3EA"/>
+                      </a:solidFill>
+                      <a:prstDash val="solid"/>
+                      <a:round/>
+                      <a:headEnd type="none" w="med" len="med"/>
+                      <a:tailEnd type="none" w="med" len="med"/>
+                    </a:lnL>
+                    <a:lnR w="6350" cap="flat" cmpd="sng" algn="ctr">
+                      <a:solidFill>
+                        <a:srgbClr val="DDE3EA"/>
+                      </a:solidFill>
+                      <a:prstDash val="solid"/>
+                      <a:round/>
+                      <a:headEnd type="none" w="med" len="med"/>
+                      <a:tailEnd type="none" w="med" len="med"/>
+                    </a:lnR>
+                    <a:lnT w="6350" cap="flat" cmpd="sng" algn="ctr">
+                      <a:solidFill>
+                        <a:srgbClr val="DDE3EA"/>
+                      </a:solidFill>
+                      <a:prstDash val="solid"/>
+                      <a:round/>
+                      <a:headEnd type="none" w="med" len="med"/>
+                      <a:tailEnd type="none" w="med" len="med"/>
+                    </a:lnT>
+                    <a:lnB w="6350" cap="flat" cmpd="sng" algn="ctr">
+                      <a:solidFill>
+                        <a:srgbClr val="DDE3EA"/>
+                      </a:solidFill>
+                      <a:prstDash val="solid"/>
+                      <a:round/>
+                      <a:headEnd type="none" w="med" len="med"/>
+                      <a:tailEnd type="none" w="med" len="med"/>
+                    </a:lnB>
+                    <a:solidFill>
+                      <a:srgbClr val="EEF2F6"/>
+                    </a:solidFill>
+                  </a:tcPr>
+                </a:tc>
+                <a:tc>
+                  <a:txBody>
+                    <a:bodyPr/>
+                    <a:lstStyle/>
+                    <a:p>
+                      <a:pPr indent="0" marL="0">
+                        <a:buNone/>
+                      </a:pPr>
+                      <a:r>
+                        <a:rPr lang="en-US" sz="1400" dirty="0">
+                          <a:solidFill>
+                            <a:srgbClr val="1B2A41"/>
+                          </a:solidFill>
+                          <a:latin typeface="Calibri" pitchFamily="34" charset="0"/>
+                          <a:ea typeface="Calibri" pitchFamily="34" charset="-122"/>
+                          <a:cs typeface="Calibri" pitchFamily="34" charset="-120"/>
+                        </a:rPr>
+                        <a:t>2 quarters</a:t>
+                      </a:r>
+                      <a:endParaRPr lang="en-US" sz="1400" dirty="0">
+                        <a:latin typeface="Calibri" charset="0"/>
+                        <a:ea typeface="Calibri" charset="0"/>
+                        <a:cs typeface="Calibri" charset="0"/>
+                      </a:endParaRPr>
+                    </a:p>
+                  </a:txBody>
+                  <a:tcPr marL="91440" marR="91440" marT="45720" marB="45720" anchor="ctr">
+                    <a:lnL w="6350" cap="flat" cmpd="sng" algn="ctr">
+                      <a:solidFill>
+                        <a:srgbClr val="DDE3EA"/>
+                      </a:solidFill>
+                      <a:prstDash val="solid"/>
+                      <a:round/>
+                      <a:headEnd type="none" w="med" len="med"/>
+                      <a:tailEnd type="none" w="med" len="med"/>
+                    </a:lnL>
+                    <a:lnR w="6350" cap="flat" cmpd="sng" algn="ctr">
+                      <a:solidFill>
+                        <a:srgbClr val="DDE3EA"/>
+                      </a:solidFill>
+                      <a:prstDash val="solid"/>
+                      <a:round/>
+                      <a:headEnd type="none" w="med" len="med"/>
+                      <a:tailEnd type="none" w="med" len="med"/>
+                    </a:lnR>
+                    <a:lnT w="6350" cap="flat" cmpd="sng" algn="ctr">
+                      <a:solidFill>
+                        <a:srgbClr val="DDE3EA"/>
+                      </a:solidFill>
+                      <a:prstDash val="solid"/>
+                      <a:round/>
+                      <a:headEnd type="none" w="med" len="med"/>
+                      <a:tailEnd type="none" w="med" len="med"/>
+                    </a:lnT>
+                    <a:lnB w="6350" cap="flat" cmpd="sng" algn="ctr">
+                      <a:solidFill>
+                        <a:srgbClr val="DDE3EA"/>
+                      </a:solidFill>
+                      <a:prstDash val="solid"/>
+                      <a:round/>
+                      <a:headEnd type="none" w="med" len="med"/>
+                      <a:tailEnd type="none" w="med" len="med"/>
+                    </a:lnB>
+                    <a:solidFill>
+                      <a:srgbClr val="EEF2F6"/>
+                    </a:solidFill>
+                  </a:tcPr>
+                </a:tc>
+              </a:tr>
+              <a:tr h="548640">
+                <a:tc>
+                  <a:txBody>
+                    <a:bodyPr/>
+                    <a:lstStyle/>
+                    <a:p>
+                      <a:pPr indent="0" marL="0">
+                        <a:buNone/>
+                      </a:pPr>
+                      <a:r>
+                        <a:rPr lang="en-US" sz="1400" b="1" dirty="0">
+                          <a:solidFill>
+                            <a:srgbClr val="1B2A41"/>
+                          </a:solidFill>
+                          <a:latin typeface="Calibri" pitchFamily="34" charset="0"/>
+                          <a:ea typeface="Calibri" pitchFamily="34" charset="-122"/>
+                          <a:cs typeface="Calibri" pitchFamily="34" charset="-120"/>
+                        </a:rPr>
+                        <a:t>X4 Fix safety</a:t>
+                      </a:r>
+                      <a:endParaRPr lang="en-US" sz="1400" dirty="0">
+                        <a:latin typeface="Calibri" charset="0"/>
+                        <a:ea typeface="Calibri" charset="0"/>
+                        <a:cs typeface="Calibri" charset="0"/>
+                      </a:endParaRPr>
+                    </a:p>
+                  </a:txBody>
+                  <a:tcPr marL="91440" marR="91440" marT="45720" marB="45720" anchor="ctr">
+                    <a:lnL w="6350" cap="flat" cmpd="sng" algn="ctr">
+                      <a:solidFill>
+                        <a:srgbClr val="DDE3EA"/>
+                      </a:solidFill>
+                      <a:prstDash val="solid"/>
+                      <a:round/>
+                      <a:headEnd type="none" w="med" len="med"/>
+                      <a:tailEnd type="none" w="med" len="med"/>
+                    </a:lnL>
+                    <a:lnR w="6350" cap="flat" cmpd="sng" algn="ctr">
+                      <a:solidFill>
+                        <a:srgbClr val="DDE3EA"/>
+                      </a:solidFill>
+                      <a:prstDash val="solid"/>
+                      <a:round/>
+                      <a:headEnd type="none" w="med" len="med"/>
+                      <a:tailEnd type="none" w="med" len="med"/>
+                    </a:lnR>
+                    <a:lnT w="6350" cap="flat" cmpd="sng" algn="ctr">
+                      <a:solidFill>
+                        <a:srgbClr val="DDE3EA"/>
+                      </a:solidFill>
+                      <a:prstDash val="solid"/>
+                      <a:round/>
+                      <a:headEnd type="none" w="med" len="med"/>
+                      <a:tailEnd type="none" w="med" len="med"/>
+                    </a:lnT>
+                    <a:lnB w="6350" cap="flat" cmpd="sng" algn="ctr">
+                      <a:solidFill>
+                        <a:srgbClr val="DDE3EA"/>
+                      </a:solidFill>
+                      <a:prstDash val="solid"/>
+                      <a:round/>
+                      <a:headEnd type="none" w="med" len="med"/>
+                      <a:tailEnd type="none" w="med" len="med"/>
+                    </a:lnB>
+                    <a:solidFill>
+                      <a:srgbClr val="FFFFFF"/>
+                    </a:solidFill>
+                  </a:tcPr>
+                </a:tc>
+                <a:tc>
+                  <a:txBody>
+                    <a:bodyPr/>
+                    <a:lstStyle/>
+                    <a:p>
+                      <a:pPr indent="0" marL="0">
+                        <a:buNone/>
+                      </a:pPr>
+                      <a:r>
+                        <a:rPr lang="en-US" sz="1400" dirty="0">
+                          <a:solidFill>
+                            <a:srgbClr val="1B2A41"/>
+                          </a:solidFill>
+                          <a:latin typeface="Calibri" pitchFamily="34" charset="0"/>
+                          <a:ea typeface="Calibri" pitchFamily="34" charset="-122"/>
+                          <a:cs typeface="Calibri" pitchFamily="34" charset="-120"/>
+                        </a:rPr>
+                        <a:t>Same pool, bug-fix PRs only</a:t>
+                      </a:r>
+                      <a:endParaRPr lang="en-US" sz="1400" dirty="0">
+                        <a:latin typeface="Calibri" charset="0"/>
+                        <a:ea typeface="Calibri" charset="0"/>
+                        <a:cs typeface="Calibri" charset="0"/>
+                      </a:endParaRPr>
+                    </a:p>
+                  </a:txBody>
+                  <a:tcPr marL="91440" marR="91440" marT="45720" marB="45720" anchor="ctr">
+                    <a:lnL w="6350" cap="flat" cmpd="sng" algn="ctr">
+                      <a:solidFill>
+                        <a:srgbClr val="DDE3EA"/>
+                      </a:solidFill>
+                      <a:prstDash val="solid"/>
+                      <a:round/>
+                      <a:headEnd type="none" w="med" len="med"/>
+                      <a:tailEnd type="none" w="med" len="med"/>
+                    </a:lnL>
+                    <a:lnR w="6350" cap="flat" cmpd="sng" algn="ctr">
+                      <a:solidFill>
+                        <a:srgbClr val="DDE3EA"/>
+                      </a:solidFill>
+                      <a:prstDash val="solid"/>
+                      <a:round/>
+                      <a:headEnd type="none" w="med" len="med"/>
+                      <a:tailEnd type="none" w="med" len="med"/>
+                    </a:lnR>
+                    <a:lnT w="6350" cap="flat" cmpd="sng" algn="ctr">
+                      <a:solidFill>
+                        <a:srgbClr val="DDE3EA"/>
+                      </a:solidFill>
+                      <a:prstDash val="solid"/>
+                      <a:round/>
+                      <a:headEnd type="none" w="med" len="med"/>
+                      <a:tailEnd type="none" w="med" len="med"/>
+                    </a:lnT>
+                    <a:lnB w="6350" cap="flat" cmpd="sng" algn="ctr">
+                      <a:solidFill>
+                        <a:srgbClr val="DDE3EA"/>
+                      </a:solidFill>
+                      <a:prstDash val="solid"/>
+                      <a:round/>
+                      <a:headEnd type="none" w="med" len="med"/>
+                      <a:tailEnd type="none" w="med" len="med"/>
+                    </a:lnB>
+                    <a:solidFill>
+                      <a:srgbClr val="FFFFFF"/>
+                    </a:solidFill>
+                  </a:tcPr>
+                </a:tc>
+                <a:tc>
+                  <a:txBody>
+                    <a:bodyPr/>
+                    <a:lstStyle/>
+                    <a:p>
+                      <a:pPr indent="0" marL="0">
+                        <a:buNone/>
+                      </a:pPr>
+                      <a:r>
+                        <a:rPr lang="en-US" sz="1400" dirty="0">
+                          <a:solidFill>
+                            <a:srgbClr val="1B2A41"/>
+                          </a:solidFill>
+                          <a:latin typeface="Calibri" pitchFamily="34" charset="0"/>
+                          <a:ea typeface="Calibri" pitchFamily="34" charset="-122"/>
+                          <a:cs typeface="Calibri" pitchFamily="34" charset="-120"/>
+                        </a:rPr>
+                        <a:t>Follow-up fixes per bug-fix PR</a:t>
+                      </a:r>
+                      <a:endParaRPr lang="en-US" sz="1400" dirty="0">
+                        <a:latin typeface="Calibri" charset="0"/>
+                        <a:ea typeface="Calibri" charset="0"/>
+                        <a:cs typeface="Calibri" charset="0"/>
+                      </a:endParaRPr>
+                    </a:p>
+                  </a:txBody>
+                  <a:tcPr marL="91440" marR="91440" marT="45720" marB="45720" anchor="ctr">
+                    <a:lnL w="6350" cap="flat" cmpd="sng" algn="ctr">
+                      <a:solidFill>
+                        <a:srgbClr val="DDE3EA"/>
+                      </a:solidFill>
+                      <a:prstDash val="solid"/>
+                      <a:round/>
+                      <a:headEnd type="none" w="med" len="med"/>
+                      <a:tailEnd type="none" w="med" len="med"/>
+                    </a:lnL>
+                    <a:lnR w="6350" cap="flat" cmpd="sng" algn="ctr">
+                      <a:solidFill>
+                        <a:srgbClr val="DDE3EA"/>
+                      </a:solidFill>
+                      <a:prstDash val="solid"/>
+                      <a:round/>
+                      <a:headEnd type="none" w="med" len="med"/>
+                      <a:tailEnd type="none" w="med" len="med"/>
+                    </a:lnR>
+                    <a:lnT w="6350" cap="flat" cmpd="sng" algn="ctr">
+                      <a:solidFill>
+                        <a:srgbClr val="DDE3EA"/>
+                      </a:solidFill>
+                      <a:prstDash val="solid"/>
+                      <a:round/>
+                      <a:headEnd type="none" w="med" len="med"/>
+                      <a:tailEnd type="none" w="med" len="med"/>
+                    </a:lnT>
+                    <a:lnB w="6350" cap="flat" cmpd="sng" algn="ctr">
+                      <a:solidFill>
+                        <a:srgbClr val="DDE3EA"/>
+                      </a:solidFill>
+                      <a:prstDash val="solid"/>
+                      <a:round/>
+                      <a:headEnd type="none" w="med" len="med"/>
+                      <a:tailEnd type="none" w="med" len="med"/>
+                    </a:lnB>
+                    <a:solidFill>
+                      <a:srgbClr val="FFFFFF"/>
+                    </a:solidFill>
+                  </a:tcPr>
+                </a:tc>
+                <a:tc>
+                  <a:txBody>
+                    <a:bodyPr/>
+                    <a:lstStyle/>
+                    <a:p>
+                      <a:pPr indent="0" marL="0">
+                        <a:buNone/>
+                      </a:pPr>
+                      <a:r>
+                        <a:rPr lang="en-US" sz="1400" dirty="0">
+                          <a:solidFill>
+                            <a:srgbClr val="1B2A41"/>
+                          </a:solidFill>
+                          <a:latin typeface="Calibri" pitchFamily="34" charset="0"/>
+                          <a:ea typeface="Calibri" pitchFamily="34" charset="-122"/>
+                          <a:cs typeface="Calibri" pitchFamily="34" charset="-120"/>
+                        </a:rPr>
+                        <a:t>2 quarters</a:t>
+                      </a:r>
+                      <a:endParaRPr lang="en-US" sz="1400" dirty="0">
+                        <a:latin typeface="Calibri" charset="0"/>
+                        <a:ea typeface="Calibri" charset="0"/>
+                        <a:cs typeface="Calibri" charset="0"/>
+                      </a:endParaRPr>
+                    </a:p>
+                  </a:txBody>
+                  <a:tcPr marL="91440" marR="91440" marT="45720" marB="45720" anchor="ctr">
+                    <a:lnL w="6350" cap="flat" cmpd="sng" algn="ctr">
+                      <a:solidFill>
+                        <a:srgbClr val="DDE3EA"/>
+                      </a:solidFill>
+                      <a:prstDash val="solid"/>
+                      <a:round/>
+                      <a:headEnd type="none" w="med" len="med"/>
+                      <a:tailEnd type="none" w="med" len="med"/>
+                    </a:lnL>
+                    <a:lnR w="6350" cap="flat" cmpd="sng" algn="ctr">
+                      <a:solidFill>
+                        <a:srgbClr val="DDE3EA"/>
+                      </a:solidFill>
+                      <a:prstDash val="solid"/>
+                      <a:round/>
+                      <a:headEnd type="none" w="med" len="med"/>
+                      <a:tailEnd type="none" w="med" len="med"/>
+                    </a:lnR>
+                    <a:lnT w="6350" cap="flat" cmpd="sng" algn="ctr">
+                      <a:solidFill>
+                        <a:srgbClr val="DDE3EA"/>
+                      </a:solidFill>
+                      <a:prstDash val="solid"/>
+                      <a:round/>
+                      <a:headEnd type="none" w="med" len="med"/>
+                      <a:tailEnd type="none" w="med" len="med"/>
+                    </a:lnT>
+                    <a:lnB w="6350" cap="flat" cmpd="sng" algn="ctr">
+                      <a:solidFill>
+                        <a:srgbClr val="DDE3EA"/>
+                      </a:solidFill>
+                      <a:prstDash val="solid"/>
+                      <a:round/>
+                      <a:headEnd type="none" w="med" len="med"/>
+                      <a:tailEnd type="none" w="med" len="med"/>
+                    </a:lnB>
+                    <a:solidFill>
+                      <a:srgbClr val="FFFFFF"/>
+                    </a:solidFill>
+                  </a:tcPr>
+                </a:tc>
+              </a:tr>
+              <a:tr h="548640">
+                <a:tc>
+                  <a:txBody>
+                    <a:bodyPr/>
+                    <a:lstStyle/>
+                    <a:p>
+                      <a:pPr indent="0" marL="0">
+                        <a:buNone/>
+                      </a:pPr>
+                      <a:r>
+                        <a:rPr lang="en-US" sz="1400" b="1" dirty="0">
+                          <a:solidFill>
+                            <a:srgbClr val="1B2A41"/>
+                          </a:solidFill>
+                          <a:latin typeface="Calibri" pitchFamily="34" charset="0"/>
+                          <a:ea typeface="Calibri" pitchFamily="34" charset="-122"/>
+                          <a:cs typeface="Calibri" pitchFamily="34" charset="-120"/>
+                        </a:rPr>
+                        <a:t>X5 Expectation gaps</a:t>
+                      </a:r>
+                      <a:endParaRPr lang="en-US" sz="1400" dirty="0">
+                        <a:latin typeface="Calibri" charset="0"/>
+                        <a:ea typeface="Calibri" charset="0"/>
+                        <a:cs typeface="Calibri" charset="0"/>
+                      </a:endParaRPr>
+                    </a:p>
+                  </a:txBody>
+                  <a:tcPr marL="91440" marR="91440" marT="45720" marB="45720" anchor="ctr">
+                    <a:lnL w="6350" cap="flat" cmpd="sng" algn="ctr">
+                      <a:solidFill>
+                        <a:srgbClr val="DDE3EA"/>
+                      </a:solidFill>
+                      <a:prstDash val="solid"/>
+                      <a:round/>
+                      <a:headEnd type="none" w="med" len="med"/>
+                      <a:tailEnd type="none" w="med" len="med"/>
+                    </a:lnL>
+                    <a:lnR w="6350" cap="flat" cmpd="sng" algn="ctr">
+                      <a:solidFill>
+                        <a:srgbClr val="DDE3EA"/>
+                      </a:solidFill>
+                      <a:prstDash val="solid"/>
+                      <a:round/>
+                      <a:headEnd type="none" w="med" len="med"/>
+                      <a:tailEnd type="none" w="med" len="med"/>
+                    </a:lnR>
+                    <a:lnT w="6350" cap="flat" cmpd="sng" algn="ctr">
+                      <a:solidFill>
+                        <a:srgbClr val="DDE3EA"/>
+                      </a:solidFill>
+                      <a:prstDash val="solid"/>
+                      <a:round/>
+                      <a:headEnd type="none" w="med" len="med"/>
+                      <a:tailEnd type="none" w="med" len="med"/>
+                    </a:lnT>
+                    <a:lnB w="6350" cap="flat" cmpd="sng" algn="ctr">
+                      <a:solidFill>
+                        <a:srgbClr val="DDE3EA"/>
+                      </a:solidFill>
+                      <a:prstDash val="solid"/>
+                      <a:round/>
+                      <a:headEnd type="none" w="med" len="med"/>
+                      <a:tailEnd type="none" w="med" len="med"/>
+                    </a:lnB>
+                    <a:solidFill>
+                      <a:srgbClr val="EEF2F6"/>
+                    </a:solidFill>
+                  </a:tcPr>
+                </a:tc>
+                <a:tc>
+                  <a:txBody>
+                    <a:bodyPr/>
+                    <a:lstStyle/>
+                    <a:p>
+                      <a:pPr indent="0" marL="0">
+                        <a:buNone/>
+                      </a:pPr>
+                      <a:r>
+                        <a:rPr lang="en-US" sz="1400" dirty="0">
+                          <a:solidFill>
+                            <a:srgbClr val="1B2A41"/>
+                          </a:solidFill>
+                          <a:latin typeface="Calibri" pitchFamily="34" charset="0"/>
+                          <a:ea typeface="Calibri" pitchFamily="34" charset="-122"/>
+                          <a:cs typeface="Calibri" pitchFamily="34" charset="-120"/>
+                        </a:rPr>
+                        <a:t>5 high-noise teams + VMS/QM, WFM</a:t>
+                      </a:r>
+                      <a:endParaRPr lang="en-US" sz="1400" dirty="0">
+                        <a:latin typeface="Calibri" charset="0"/>
+                        <a:ea typeface="Calibri" charset="0"/>
+                        <a:cs typeface="Calibri" charset="0"/>
+                      </a:endParaRPr>
+                    </a:p>
+                  </a:txBody>
+                  <a:tcPr marL="91440" marR="91440" marT="45720" marB="45720" anchor="ctr">
+                    <a:lnL w="6350" cap="flat" cmpd="sng" algn="ctr">
+                      <a:solidFill>
+                        <a:srgbClr val="DDE3EA"/>
+                      </a:solidFill>
+                      <a:prstDash val="solid"/>
+                      <a:round/>
+                      <a:headEnd type="none" w="med" len="med"/>
+                      <a:tailEnd type="none" w="med" len="med"/>
+                    </a:lnL>
+                    <a:lnR w="6350" cap="flat" cmpd="sng" algn="ctr">
+                      <a:solidFill>
+                        <a:srgbClr val="DDE3EA"/>
+                      </a:solidFill>
+                      <a:prstDash val="solid"/>
+                      <a:round/>
+                      <a:headEnd type="none" w="med" len="med"/>
+                      <a:tailEnd type="none" w="med" len="med"/>
+                    </a:lnR>
+                    <a:lnT w="6350" cap="flat" cmpd="sng" algn="ctr">
+                      <a:solidFill>
+                        <a:srgbClr val="DDE3EA"/>
+                      </a:solidFill>
+                      <a:prstDash val="solid"/>
+                      <a:round/>
+                      <a:headEnd type="none" w="med" len="med"/>
+                      <a:tailEnd type="none" w="med" len="med"/>
+                    </a:lnT>
+                    <a:lnB w="6350" cap="flat" cmpd="sng" algn="ctr">
+                      <a:solidFill>
+                        <a:srgbClr val="DDE3EA"/>
+                      </a:solidFill>
+                      <a:prstDash val="solid"/>
+                      <a:round/>
+                      <a:headEnd type="none" w="med" len="med"/>
+                      <a:tailEnd type="none" w="med" len="med"/>
+                    </a:lnB>
+                    <a:solidFill>
+                      <a:srgbClr val="EEF2F6"/>
+                    </a:solidFill>
+                  </a:tcPr>
+                </a:tc>
+                <a:tc>
+                  <a:txBody>
+                    <a:bodyPr/>
+                    <a:lstStyle/>
+                    <a:p>
+                      <a:pPr indent="0" marL="0">
+                        <a:buNone/>
+                      </a:pPr>
+                      <a:r>
+                        <a:rPr lang="en-US" sz="1400" dirty="0">
+                          <a:solidFill>
+                            <a:srgbClr val="1B2A41"/>
+                          </a:solidFill>
+                          <a:latin typeface="Calibri" pitchFamily="34" charset="0"/>
+                          <a:ea typeface="Calibri" pitchFamily="34" charset="-122"/>
+                          <a:cs typeface="Calibri" pitchFamily="34" charset="-120"/>
+                        </a:rPr>
+                        <a:t>Share of 'works as designed' closures with an action</a:t>
+                      </a:r>
+                      <a:endParaRPr lang="en-US" sz="1400" dirty="0">
+                        <a:latin typeface="Calibri" charset="0"/>
+                        <a:ea typeface="Calibri" charset="0"/>
+                        <a:cs typeface="Calibri" charset="0"/>
+                      </a:endParaRPr>
+                    </a:p>
+                  </a:txBody>
+                  <a:tcPr marL="91440" marR="91440" marT="45720" marB="45720" anchor="ctr">
+                    <a:lnL w="6350" cap="flat" cmpd="sng" algn="ctr">
+                      <a:solidFill>
+                        <a:srgbClr val="DDE3EA"/>
+                      </a:solidFill>
+                      <a:prstDash val="solid"/>
+                      <a:round/>
+                      <a:headEnd type="none" w="med" len="med"/>
+                      <a:tailEnd type="none" w="med" len="med"/>
+                    </a:lnL>
+                    <a:lnR w="6350" cap="flat" cmpd="sng" algn="ctr">
+                      <a:solidFill>
+                        <a:srgbClr val="DDE3EA"/>
+                      </a:solidFill>
+                      <a:prstDash val="solid"/>
+                      <a:round/>
+                      <a:headEnd type="none" w="med" len="med"/>
+                      <a:tailEnd type="none" w="med" len="med"/>
+                    </a:lnR>
+                    <a:lnT w="6350" cap="flat" cmpd="sng" algn="ctr">
+                      <a:solidFill>
+                        <a:srgbClr val="DDE3EA"/>
+                      </a:solidFill>
+                      <a:prstDash val="solid"/>
+                      <a:round/>
+                      <a:headEnd type="none" w="med" len="med"/>
+                      <a:tailEnd type="none" w="med" len="med"/>
+                    </a:lnT>
+                    <a:lnB w="6350" cap="flat" cmpd="sng" algn="ctr">
+                      <a:solidFill>
+                        <a:srgbClr val="DDE3EA"/>
+                      </a:solidFill>
+                      <a:prstDash val="solid"/>
+                      <a:round/>
+                      <a:headEnd type="none" w="med" len="med"/>
+                      <a:tailEnd type="none" w="med" len="med"/>
+                    </a:lnB>
+                    <a:solidFill>
+                      <a:srgbClr val="EEF2F6"/>
+                    </a:solidFill>
+                  </a:tcPr>
+                </a:tc>
+                <a:tc>
+                  <a:txBody>
+                    <a:bodyPr/>
+                    <a:lstStyle/>
+                    <a:p>
+                      <a:pPr indent="0" marL="0">
+                        <a:buNone/>
+                      </a:pPr>
+                      <a:r>
+                        <a:rPr lang="en-US" sz="1400" dirty="0">
+                          <a:solidFill>
+                            <a:srgbClr val="1B2A41"/>
+                          </a:solidFill>
+                          <a:latin typeface="Calibri" pitchFamily="34" charset="0"/>
+                          <a:ea typeface="Calibri" pitchFamily="34" charset="-122"/>
+                          <a:cs typeface="Calibri" pitchFamily="34" charset="-120"/>
+                        </a:rPr>
+                        <a:t>1 quarter</a:t>
+                      </a:r>
+                      <a:endParaRPr lang="en-US" sz="1400" dirty="0">
+                        <a:latin typeface="Calibri" charset="0"/>
+                        <a:ea typeface="Calibri" charset="0"/>
+                        <a:cs typeface="Calibri" charset="0"/>
+                      </a:endParaRPr>
+                    </a:p>
+                  </a:txBody>
+                  <a:tcPr marL="91440" marR="91440" marT="45720" marB="45720" anchor="ctr">
+                    <a:lnL w="6350" cap="flat" cmpd="sng" algn="ctr">
+                      <a:solidFill>
+                        <a:srgbClr val="DDE3EA"/>
+                      </a:solidFill>
+                      <a:prstDash val="solid"/>
+                      <a:round/>
+                      <a:headEnd type="none" w="med" len="med"/>
+                      <a:tailEnd type="none" w="med" len="med"/>
+                    </a:lnL>
+                    <a:lnR w="6350" cap="flat" cmpd="sng" algn="ctr">
+                      <a:solidFill>
+                        <a:srgbClr val="DDE3EA"/>
+                      </a:solidFill>
+                      <a:prstDash val="solid"/>
+                      <a:round/>
+                      <a:headEnd type="none" w="med" len="med"/>
+                      <a:tailEnd type="none" w="med" len="med"/>
+                    </a:lnR>
+                    <a:lnT w="6350" cap="flat" cmpd="sng" algn="ctr">
+                      <a:solidFill>
+                        <a:srgbClr val="DDE3EA"/>
+                      </a:solidFill>
+                      <a:prstDash val="solid"/>
+                      <a:round/>
+                      <a:headEnd type="none" w="med" len="med"/>
+                      <a:tailEnd type="none" w="med" len="med"/>
+                    </a:lnT>
+                    <a:lnB w="6350" cap="flat" cmpd="sng" algn="ctr">
+                      <a:solidFill>
+                        <a:srgbClr val="DDE3EA"/>
+                      </a:solidFill>
+                      <a:prstDash val="solid"/>
+                      <a:round/>
+                      <a:headEnd type="none" w="med" len="med"/>
+                      <a:tailEnd type="none" w="med" len="med"/>
+                    </a:lnB>
+                    <a:solidFill>
+                      <a:srgbClr val="EEF2F6"/>
+                    </a:solidFill>
+                  </a:tcPr>
+                </a:tc>
+              </a:tr>
+            </a:tbl>
+          </a:graphicData>
+        </a:graphic>
+      </p:graphicFrame>
+      <p:sp>
+        <p:nvSpPr>
+          <p:cNvPr id="4" name="power-note"/>
           <p:cNvSpPr/>
           <p:nvPr/>
         </p:nvSpPr>
         <p:spPr>
           <a:xfrm>
-            <a:off x="548640" y="1463040"/>
-            <a:ext cx="548640" cy="548640"/>
-          </a:xfrm>
-          <a:prstGeom prst="ellipse">
-            <a:avLst/>
+            <a:off x="548640" y="4892040"/>
+            <a:ext cx="11064240" cy="1234440"/>
+          </a:xfrm>
+          <a:prstGeom prst="roundRect">
+            <a:avLst>
+              <a:gd name="adj" fmla="val 5926"/>
+            </a:avLst>
           </a:prstGeom>
           <a:solidFill>
-            <a:schemeClr val="accent2"/>
+            <a:schemeClr val="bg2"/>
           </a:solidFill>
           <a:ln w="12700">
             <a:solidFill>
-              <a:schemeClr val="accent2"/>
+              <a:schemeClr val="bg2"/>
             </a:solidFill>
             <a:prstDash val="solid"/>
           </a:ln>
@@ -3918,14 +5596,14 @@
       </p:sp>
       <p:sp>
         <p:nvSpPr>
-          <p:cNvPr id="4" name="Text 2"/>
+          <p:cNvPr id="5" name="Text 2"/>
           <p:cNvSpPr txBox="1"/>
           <p:nvPr/>
         </p:nvSpPr>
         <p:spPr>
           <a:xfrm>
-            <a:off x="548640" y="1463040"/>
-            <a:ext cx="548640" cy="548640"/>
+            <a:off x="777240" y="4983480"/>
+            <a:ext cx="10607040" cy="1051560"/>
           </a:xfrm>
           <a:prstGeom prst="rect">
             <a:avLst/>
@@ -3937,836 +5615,27 @@
           <a:bodyPr wrap="square" lIns="0" tIns="0" rIns="0" bIns="0" rtlCol="0" anchor="ctr"/>
           <a:lstStyle/>
           <a:p>
-            <a:pPr algn="ctr" indent="0" marL="0">
-              <a:buNone/>
-            </a:pPr>
-            <a:r>
-              <a:rPr lang="en-US" sz="1600" b="1" dirty="0">
-                <a:solidFill>
-                  <a:schemeClr val="bg1"/>
-                </a:solidFill>
-              </a:rPr>
-              <a:t>1</a:t>
-            </a:r>
-            <a:endParaRPr lang="en-US" sz="1600" dirty="0"/>
-          </a:p>
-        </p:txBody>
-      </p:sp>
-      <p:sp>
-        <p:nvSpPr>
-          <p:cNvPr id="5" name="Text 3"/>
-          <p:cNvSpPr txBox="1"/>
-          <p:nvPr/>
-        </p:nvSpPr>
-        <p:spPr>
-          <a:xfrm>
-            <a:off x="1325880" y="1371600"/>
-            <a:ext cx="4480560" cy="731520"/>
-          </a:xfrm>
-          <a:prstGeom prst="rect">
-            <a:avLst/>
-          </a:prstGeom>
-          <a:noFill/>
-          <a:ln/>
-        </p:spPr>
-        <p:txBody>
-          <a:bodyPr wrap="square" lIns="0" tIns="0" rIns="0" bIns="0" rtlCol="0" anchor="ctr"/>
-          <a:lstStyle/>
-          <a:p>
             <a:pPr indent="0" marL="0">
               <a:buNone/>
             </a:pPr>
             <a:r>
-              <a:rPr lang="en-US" sz="1700" b="1" dirty="0">
-                <a:solidFill>
-                  <a:schemeClr val="tx1"/>
+              <a:rPr lang="en-US" sz="1400" b="1" dirty="0">
+                <a:solidFill>
+                  <a:srgbClr val="C8443D"/>
                 </a:solidFill>
               </a:rPr>
-              <a:t>Intake rule and required fields</a:t>
-            </a:r>
-            <a:endParaRPr lang="en-US" sz="1700" dirty="0"/>
-          </a:p>
-        </p:txBody>
-      </p:sp>
-      <p:sp>
-        <p:nvSpPr>
-          <p:cNvPr id="6" name="Text 4"/>
-          <p:cNvSpPr txBox="1"/>
-          <p:nvPr/>
-        </p:nvSpPr>
-        <p:spPr>
-          <a:xfrm>
-            <a:off x="5943600" y="1371600"/>
-            <a:ext cx="2651760" cy="731520"/>
-          </a:xfrm>
-          <a:prstGeom prst="rect">
-            <a:avLst/>
-          </a:prstGeom>
-          <a:noFill/>
-          <a:ln/>
-        </p:spPr>
-        <p:txBody>
-          <a:bodyPr wrap="square" lIns="0" tIns="0" rIns="0" bIns="0" rtlCol="0" anchor="ctr"/>
-          <a:lstStyle/>
-          <a:p>
+              <a:t>Power check: </a:t>
+            </a:r>
             <a:pPr indent="0" marL="0">
               <a:buNone/>
             </a:pPr>
             <a:r>
               <a:rPr lang="en-US" sz="1400" dirty="0">
                 <a:solidFill>
-                  <a:schemeClr val="tx2"/>
+                  <a:schemeClr val="tx1"/>
                 </a:solidFill>
               </a:rPr>
-              <a:t>3 teams, one per archetype</a:t>
-            </a:r>
-            <a:endParaRPr lang="en-US" sz="1400" dirty="0"/>
-          </a:p>
-        </p:txBody>
-      </p:sp>
-      <p:sp>
-        <p:nvSpPr>
-          <p:cNvPr id="7" name="Text 5"/>
-          <p:cNvSpPr txBox="1"/>
-          <p:nvPr/>
-        </p:nvSpPr>
-        <p:spPr>
-          <a:xfrm>
-            <a:off x="8686800" y="1371600"/>
-            <a:ext cx="2926080" cy="731520"/>
-          </a:xfrm>
-          <a:prstGeom prst="rect">
-            <a:avLst/>
-          </a:prstGeom>
-          <a:noFill/>
-          <a:ln/>
-        </p:spPr>
-        <p:txBody>
-          <a:bodyPr wrap="square" lIns="0" tIns="0" rIns="0" bIns="0" rtlCol="0" anchor="ctr"/>
-          <a:lstStyle/>
-          <a:p>
-            <a:pPr indent="0" marL="0">
-              <a:buNone/>
-            </a:pPr>
-            <a:r>
-              <a:rPr lang="en-US" sz="1400" dirty="0">
-                <a:solidFill>
-                  <a:schemeClr val="tx1"/>
-                </a:solidFill>
-              </a:rPr>
-              <a:t>Bugs with type, detected-by, cause</a:t>
-            </a:r>
-            <a:endParaRPr lang="en-US" sz="1400" dirty="0"/>
-          </a:p>
-        </p:txBody>
-      </p:sp>
-      <p:sp>
-        <p:nvSpPr>
-          <p:cNvPr id="8" name="num-2"/>
-          <p:cNvSpPr/>
-          <p:nvPr/>
-        </p:nvSpPr>
-        <p:spPr>
-          <a:xfrm>
-            <a:off x="548640" y="2359152"/>
-            <a:ext cx="548640" cy="548640"/>
-          </a:xfrm>
-          <a:prstGeom prst="ellipse">
-            <a:avLst/>
-          </a:prstGeom>
-          <a:solidFill>
-            <a:schemeClr val="accent2"/>
-          </a:solidFill>
-          <a:ln w="12700">
-            <a:solidFill>
-              <a:schemeClr val="accent2"/>
-            </a:solidFill>
-            <a:prstDash val="solid"/>
-          </a:ln>
-        </p:spPr>
-      </p:sp>
-      <p:sp>
-        <p:nvSpPr>
-          <p:cNvPr id="9" name="Text 7"/>
-          <p:cNvSpPr txBox="1"/>
-          <p:nvPr/>
-        </p:nvSpPr>
-        <p:spPr>
-          <a:xfrm>
-            <a:off x="548640" y="2359152"/>
-            <a:ext cx="548640" cy="548640"/>
-          </a:xfrm>
-          <a:prstGeom prst="rect">
-            <a:avLst/>
-          </a:prstGeom>
-          <a:noFill/>
-          <a:ln/>
-        </p:spPr>
-        <p:txBody>
-          <a:bodyPr wrap="square" lIns="0" tIns="0" rIns="0" bIns="0" rtlCol="0" anchor="ctr"/>
-          <a:lstStyle/>
-          <a:p>
-            <a:pPr algn="ctr" indent="0" marL="0">
-              <a:buNone/>
-            </a:pPr>
-            <a:r>
-              <a:rPr lang="en-US" sz="1600" b="1" dirty="0">
-                <a:solidFill>
-                  <a:schemeClr val="bg1"/>
-                </a:solidFill>
-              </a:rPr>
-              <a:t>2</a:t>
-            </a:r>
-            <a:endParaRPr lang="en-US" sz="1600" dirty="0"/>
-          </a:p>
-        </p:txBody>
-      </p:sp>
-      <p:sp>
-        <p:nvSpPr>
-          <p:cNvPr id="10" name="Text 8"/>
-          <p:cNvSpPr txBox="1"/>
-          <p:nvPr/>
-        </p:nvSpPr>
-        <p:spPr>
-          <a:xfrm>
-            <a:off x="1325880" y="2267712"/>
-            <a:ext cx="4480560" cy="731520"/>
-          </a:xfrm>
-          <a:prstGeom prst="rect">
-            <a:avLst/>
-          </a:prstGeom>
-          <a:noFill/>
-          <a:ln/>
-        </p:spPr>
-        <p:txBody>
-          <a:bodyPr wrap="square" lIns="0" tIns="0" rIns="0" bIns="0" rtlCol="0" anchor="ctr"/>
-          <a:lstStyle/>
-          <a:p>
-            <a:pPr indent="0" marL="0">
-              <a:buNone/>
-            </a:pPr>
-            <a:r>
-              <a:rPr lang="en-US" sz="1700" b="1" dirty="0">
-                <a:solidFill>
-                  <a:schemeClr val="tx1"/>
-                </a:solidFill>
-              </a:rPr>
-              <a:t>Monitoring for one correctness type</a:t>
-            </a:r>
-            <a:endParaRPr lang="en-US" sz="1700" dirty="0"/>
-          </a:p>
-        </p:txBody>
-      </p:sp>
-      <p:sp>
-        <p:nvSpPr>
-          <p:cNvPr id="11" name="Text 9"/>
-          <p:cNvSpPr txBox="1"/>
-          <p:nvPr/>
-        </p:nvSpPr>
-        <p:spPr>
-          <a:xfrm>
-            <a:off x="5943600" y="2267712"/>
-            <a:ext cx="2651760" cy="731520"/>
-          </a:xfrm>
-          <a:prstGeom prst="rect">
-            <a:avLst/>
-          </a:prstGeom>
-          <a:noFill/>
-          <a:ln/>
-        </p:spPr>
-        <p:txBody>
-          <a:bodyPr wrap="square" lIns="0" tIns="0" rIns="0" bIns="0" rtlCol="0" anchor="ctr"/>
-          <a:lstStyle/>
-          <a:p>
-            <a:pPr indent="0" marL="0">
-              <a:buNone/>
-            </a:pPr>
-            <a:r>
-              <a:rPr lang="en-US" sz="1400" dirty="0">
-                <a:solidFill>
-                  <a:schemeClr val="tx2"/>
-                </a:solidFill>
-              </a:rPr>
-              <a:t>1 high-impact team</a:t>
-            </a:r>
-            <a:endParaRPr lang="en-US" sz="1400" dirty="0"/>
-          </a:p>
-        </p:txBody>
-      </p:sp>
-      <p:sp>
-        <p:nvSpPr>
-          <p:cNvPr id="12" name="Text 10"/>
-          <p:cNvSpPr txBox="1"/>
-          <p:nvPr/>
-        </p:nvSpPr>
-        <p:spPr>
-          <a:xfrm>
-            <a:off x="8686800" y="2267712"/>
-            <a:ext cx="2926080" cy="731520"/>
-          </a:xfrm>
-          <a:prstGeom prst="rect">
-            <a:avLst/>
-          </a:prstGeom>
-          <a:noFill/>
-          <a:ln/>
-        </p:spPr>
-        <p:txBody>
-          <a:bodyPr wrap="square" lIns="0" tIns="0" rIns="0" bIns="0" rtlCol="0" anchor="ctr"/>
-          <a:lstStyle/>
-          <a:p>
-            <a:pPr indent="0" marL="0">
-              <a:buNone/>
-            </a:pPr>
-            <a:r>
-              <a:rPr lang="en-US" sz="1400" dirty="0">
-                <a:solidFill>
-                  <a:schemeClr val="tx1"/>
-                </a:solidFill>
-              </a:rPr>
-              <a:t>Share found before customers</a:t>
-            </a:r>
-            <a:endParaRPr lang="en-US" sz="1400" dirty="0"/>
-          </a:p>
-        </p:txBody>
-      </p:sp>
-      <p:sp>
-        <p:nvSpPr>
-          <p:cNvPr id="13" name="num-3"/>
-          <p:cNvSpPr/>
-          <p:nvPr/>
-        </p:nvSpPr>
-        <p:spPr>
-          <a:xfrm>
-            <a:off x="548640" y="3255264"/>
-            <a:ext cx="548640" cy="548640"/>
-          </a:xfrm>
-          <a:prstGeom prst="ellipse">
-            <a:avLst/>
-          </a:prstGeom>
-          <a:solidFill>
-            <a:schemeClr val="accent2"/>
-          </a:solidFill>
-          <a:ln w="12700">
-            <a:solidFill>
-              <a:schemeClr val="accent2"/>
-            </a:solidFill>
-            <a:prstDash val="solid"/>
-          </a:ln>
-        </p:spPr>
-      </p:sp>
-      <p:sp>
-        <p:nvSpPr>
-          <p:cNvPr id="14" name="Text 12"/>
-          <p:cNvSpPr txBox="1"/>
-          <p:nvPr/>
-        </p:nvSpPr>
-        <p:spPr>
-          <a:xfrm>
-            <a:off x="548640" y="3255264"/>
-            <a:ext cx="548640" cy="548640"/>
-          </a:xfrm>
-          <a:prstGeom prst="rect">
-            <a:avLst/>
-          </a:prstGeom>
-          <a:noFill/>
-          <a:ln/>
-        </p:spPr>
-        <p:txBody>
-          <a:bodyPr wrap="square" lIns="0" tIns="0" rIns="0" bIns="0" rtlCol="0" anchor="ctr"/>
-          <a:lstStyle/>
-          <a:p>
-            <a:pPr algn="ctr" indent="0" marL="0">
-              <a:buNone/>
-            </a:pPr>
-            <a:r>
-              <a:rPr lang="en-US" sz="1600" b="1" dirty="0">
-                <a:solidFill>
-                  <a:schemeClr val="bg1"/>
-                </a:solidFill>
-              </a:rPr>
-              <a:t>3</a:t>
-            </a:r>
-            <a:endParaRPr lang="en-US" sz="1600" dirty="0"/>
-          </a:p>
-        </p:txBody>
-      </p:sp>
-      <p:sp>
-        <p:nvSpPr>
-          <p:cNvPr id="15" name="Text 13"/>
-          <p:cNvSpPr txBox="1"/>
-          <p:nvPr/>
-        </p:nvSpPr>
-        <p:spPr>
-          <a:xfrm>
-            <a:off x="1325880" y="3163824"/>
-            <a:ext cx="4480560" cy="731520"/>
-          </a:xfrm>
-          <a:prstGeom prst="rect">
-            <a:avLst/>
-          </a:prstGeom>
-          <a:noFill/>
-          <a:ln/>
-        </p:spPr>
-        <p:txBody>
-          <a:bodyPr wrap="square" lIns="0" tIns="0" rIns="0" bIns="0" rtlCol="0" anchor="ctr"/>
-          <a:lstStyle/>
-          <a:p>
-            <a:pPr indent="0" marL="0">
-              <a:buNone/>
-            </a:pPr>
-            <a:r>
-              <a:rPr lang="en-US" sz="1700" b="1" dirty="0">
-                <a:solidFill>
-                  <a:schemeClr val="tx1"/>
-                </a:solidFill>
-              </a:rPr>
-              <a:t>Review depth scaled to size in hotspot code</a:t>
-            </a:r>
-            <a:endParaRPr lang="en-US" sz="1700" dirty="0"/>
-          </a:p>
-        </p:txBody>
-      </p:sp>
-      <p:sp>
-        <p:nvSpPr>
-          <p:cNvPr id="16" name="Text 14"/>
-          <p:cNvSpPr txBox="1"/>
-          <p:nvPr/>
-        </p:nvSpPr>
-        <p:spPr>
-          <a:xfrm>
-            <a:off x="5943600" y="3163824"/>
-            <a:ext cx="2651760" cy="731520"/>
-          </a:xfrm>
-          <a:prstGeom prst="rect">
-            <a:avLst/>
-          </a:prstGeom>
-          <a:noFill/>
-          <a:ln/>
-        </p:spPr>
-        <p:txBody>
-          <a:bodyPr wrap="square" lIns="0" tIns="0" rIns="0" bIns="0" rtlCol="0" anchor="ctr"/>
-          <a:lstStyle/>
-          <a:p>
-            <a:pPr indent="0" marL="0">
-              <a:buNone/>
-            </a:pPr>
-            <a:r>
-              <a:rPr lang="en-US" sz="1400" dirty="0">
-                <a:solidFill>
-                  <a:schemeClr val="tx2"/>
-                </a:solidFill>
-              </a:rPr>
-              <a:t>2 teams vs 2 matched</a:t>
-            </a:r>
-            <a:endParaRPr lang="en-US" sz="1400" dirty="0"/>
-          </a:p>
-        </p:txBody>
-      </p:sp>
-      <p:sp>
-        <p:nvSpPr>
-          <p:cNvPr id="17" name="Text 15"/>
-          <p:cNvSpPr txBox="1"/>
-          <p:nvPr/>
-        </p:nvSpPr>
-        <p:spPr>
-          <a:xfrm>
-            <a:off x="8686800" y="3163824"/>
-            <a:ext cx="2926080" cy="731520"/>
-          </a:xfrm>
-          <a:prstGeom prst="rect">
-            <a:avLst/>
-          </a:prstGeom>
-          <a:noFill/>
-          <a:ln/>
-        </p:spPr>
-        <p:txBody>
-          <a:bodyPr wrap="square" lIns="0" tIns="0" rIns="0" bIns="0" rtlCol="0" anchor="ctr"/>
-          <a:lstStyle/>
-          <a:p>
-            <a:pPr indent="0" marL="0">
-              <a:buNone/>
-            </a:pPr>
-            <a:r>
-              <a:rPr lang="en-US" sz="1400" dirty="0">
-                <a:solidFill>
-                  <a:schemeClr val="tx1"/>
-                </a:solidFill>
-              </a:rPr>
-              <a:t>90-day follow-up fixes per PR</a:t>
-            </a:r>
-            <a:endParaRPr lang="en-US" sz="1400" dirty="0"/>
-          </a:p>
-        </p:txBody>
-      </p:sp>
-      <p:sp>
-        <p:nvSpPr>
-          <p:cNvPr id="18" name="num-4"/>
-          <p:cNvSpPr/>
-          <p:nvPr/>
-        </p:nvSpPr>
-        <p:spPr>
-          <a:xfrm>
-            <a:off x="548640" y="4151376"/>
-            <a:ext cx="548640" cy="548640"/>
-          </a:xfrm>
-          <a:prstGeom prst="ellipse">
-            <a:avLst/>
-          </a:prstGeom>
-          <a:solidFill>
-            <a:schemeClr val="accent2"/>
-          </a:solidFill>
-          <a:ln w="12700">
-            <a:solidFill>
-              <a:schemeClr val="accent2"/>
-            </a:solidFill>
-            <a:prstDash val="solid"/>
-          </a:ln>
-        </p:spPr>
-      </p:sp>
-      <p:sp>
-        <p:nvSpPr>
-          <p:cNvPr id="19" name="Text 17"/>
-          <p:cNvSpPr txBox="1"/>
-          <p:nvPr/>
-        </p:nvSpPr>
-        <p:spPr>
-          <a:xfrm>
-            <a:off x="548640" y="4151376"/>
-            <a:ext cx="548640" cy="548640"/>
-          </a:xfrm>
-          <a:prstGeom prst="rect">
-            <a:avLst/>
-          </a:prstGeom>
-          <a:noFill/>
-          <a:ln/>
-        </p:spPr>
-        <p:txBody>
-          <a:bodyPr wrap="square" lIns="0" tIns="0" rIns="0" bIns="0" rtlCol="0" anchor="ctr"/>
-          <a:lstStyle/>
-          <a:p>
-            <a:pPr algn="ctr" indent="0" marL="0">
-              <a:buNone/>
-            </a:pPr>
-            <a:r>
-              <a:rPr lang="en-US" sz="1600" b="1" dirty="0">
-                <a:solidFill>
-                  <a:schemeClr val="bg1"/>
-                </a:solidFill>
-              </a:rPr>
-              <a:t>4</a:t>
-            </a:r>
-            <a:endParaRPr lang="en-US" sz="1600" dirty="0"/>
-          </a:p>
-        </p:txBody>
-      </p:sp>
-      <p:sp>
-        <p:nvSpPr>
-          <p:cNvPr id="20" name="Text 18"/>
-          <p:cNvSpPr txBox="1"/>
-          <p:nvPr/>
-        </p:nvSpPr>
-        <p:spPr>
-          <a:xfrm>
-            <a:off x="1325880" y="4059936"/>
-            <a:ext cx="4480560" cy="731520"/>
-          </a:xfrm>
-          <a:prstGeom prst="rect">
-            <a:avLst/>
-          </a:prstGeom>
-          <a:noFill/>
-          <a:ln/>
-        </p:spPr>
-        <p:txBody>
-          <a:bodyPr wrap="square" lIns="0" tIns="0" rIns="0" bIns="0" rtlCol="0" anchor="ctr"/>
-          <a:lstStyle/>
-          <a:p>
-            <a:pPr indent="0" marL="0">
-              <a:buNone/>
-            </a:pPr>
-            <a:r>
-              <a:rPr lang="en-US" sz="1700" b="1" dirty="0">
-                <a:solidFill>
-                  <a:schemeClr val="tx1"/>
-                </a:solidFill>
-              </a:rPr>
-              <a:t>Extra review for bug fixes</a:t>
-            </a:r>
-            <a:endParaRPr lang="en-US" sz="1700" dirty="0"/>
-          </a:p>
-        </p:txBody>
-      </p:sp>
-      <p:sp>
-        <p:nvSpPr>
-          <p:cNvPr id="21" name="Text 19"/>
-          <p:cNvSpPr txBox="1"/>
-          <p:nvPr/>
-        </p:nvSpPr>
-        <p:spPr>
-          <a:xfrm>
-            <a:off x="5943600" y="4059936"/>
-            <a:ext cx="2651760" cy="731520"/>
-          </a:xfrm>
-          <a:prstGeom prst="rect">
-            <a:avLst/>
-          </a:prstGeom>
-          <a:noFill/>
-          <a:ln/>
-        </p:spPr>
-        <p:txBody>
-          <a:bodyPr wrap="square" lIns="0" tIns="0" rIns="0" bIns="0" rtlCol="0" anchor="ctr"/>
-          <a:lstStyle/>
-          <a:p>
-            <a:pPr indent="0" marL="0">
-              <a:buNone/>
-            </a:pPr>
-            <a:r>
-              <a:rPr lang="en-US" sz="1400" dirty="0">
-                <a:solidFill>
-                  <a:schemeClr val="tx2"/>
-                </a:solidFill>
-              </a:rPr>
-              <a:t>2 teams vs 2 matched</a:t>
-            </a:r>
-            <a:endParaRPr lang="en-US" sz="1400" dirty="0"/>
-          </a:p>
-        </p:txBody>
-      </p:sp>
-      <p:sp>
-        <p:nvSpPr>
-          <p:cNvPr id="22" name="Text 20"/>
-          <p:cNvSpPr txBox="1"/>
-          <p:nvPr/>
-        </p:nvSpPr>
-        <p:spPr>
-          <a:xfrm>
-            <a:off x="8686800" y="4059936"/>
-            <a:ext cx="2926080" cy="731520"/>
-          </a:xfrm>
-          <a:prstGeom prst="rect">
-            <a:avLst/>
-          </a:prstGeom>
-          <a:noFill/>
-          <a:ln/>
-        </p:spPr>
-        <p:txBody>
-          <a:bodyPr wrap="square" lIns="0" tIns="0" rIns="0" bIns="0" rtlCol="0" anchor="ctr"/>
-          <a:lstStyle/>
-          <a:p>
-            <a:pPr indent="0" marL="0">
-              <a:buNone/>
-            </a:pPr>
-            <a:r>
-              <a:rPr lang="en-US" sz="1400" dirty="0">
-                <a:solidFill>
-                  <a:schemeClr val="tx1"/>
-                </a:solidFill>
-              </a:rPr>
-              <a:t>Fix-caused share of new bugs</a:t>
-            </a:r>
-            <a:endParaRPr lang="en-US" sz="1400" dirty="0"/>
-          </a:p>
-        </p:txBody>
-      </p:sp>
-      <p:sp>
-        <p:nvSpPr>
-          <p:cNvPr id="23" name="num-5"/>
-          <p:cNvSpPr/>
-          <p:nvPr/>
-        </p:nvSpPr>
-        <p:spPr>
-          <a:xfrm>
-            <a:off x="548640" y="5047488"/>
-            <a:ext cx="548640" cy="548640"/>
-          </a:xfrm>
-          <a:prstGeom prst="ellipse">
-            <a:avLst/>
-          </a:prstGeom>
-          <a:solidFill>
-            <a:schemeClr val="accent2"/>
-          </a:solidFill>
-          <a:ln w="12700">
-            <a:solidFill>
-              <a:schemeClr val="accent2"/>
-            </a:solidFill>
-            <a:prstDash val="solid"/>
-          </a:ln>
-        </p:spPr>
-      </p:sp>
-      <p:sp>
-        <p:nvSpPr>
-          <p:cNvPr id="24" name="Text 22"/>
-          <p:cNvSpPr txBox="1"/>
-          <p:nvPr/>
-        </p:nvSpPr>
-        <p:spPr>
-          <a:xfrm>
-            <a:off x="548640" y="5047488"/>
-            <a:ext cx="548640" cy="548640"/>
-          </a:xfrm>
-          <a:prstGeom prst="rect">
-            <a:avLst/>
-          </a:prstGeom>
-          <a:noFill/>
-          <a:ln/>
-        </p:spPr>
-        <p:txBody>
-          <a:bodyPr wrap="square" lIns="0" tIns="0" rIns="0" bIns="0" rtlCol="0" anchor="ctr"/>
-          <a:lstStyle/>
-          <a:p>
-            <a:pPr algn="ctr" indent="0" marL="0">
-              <a:buNone/>
-            </a:pPr>
-            <a:r>
-              <a:rPr lang="en-US" sz="1600" b="1" dirty="0">
-                <a:solidFill>
-                  <a:schemeClr val="bg1"/>
-                </a:solidFill>
-              </a:rPr>
-              <a:t>5</a:t>
-            </a:r>
-            <a:endParaRPr lang="en-US" sz="1600" dirty="0"/>
-          </a:p>
-        </p:txBody>
-      </p:sp>
-      <p:sp>
-        <p:nvSpPr>
-          <p:cNvPr id="25" name="Text 23"/>
-          <p:cNvSpPr txBox="1"/>
-          <p:nvPr/>
-        </p:nvSpPr>
-        <p:spPr>
-          <a:xfrm>
-            <a:off x="1325880" y="4956048"/>
-            <a:ext cx="4480560" cy="731520"/>
-          </a:xfrm>
-          <a:prstGeom prst="rect">
-            <a:avLst/>
-          </a:prstGeom>
-          <a:noFill/>
-          <a:ln/>
-        </p:spPr>
-        <p:txBody>
-          <a:bodyPr wrap="square" lIns="0" tIns="0" rIns="0" bIns="0" rtlCol="0" anchor="ctr"/>
-          <a:lstStyle/>
-          <a:p>
-            <a:pPr indent="0" marL="0">
-              <a:buNone/>
-            </a:pPr>
-            <a:r>
-              <a:rPr lang="en-US" sz="1700" b="1" dirty="0">
-                <a:solidFill>
-                  <a:schemeClr val="tx1"/>
-                </a:solidFill>
-              </a:rPr>
-              <a:t>Expectation-gap triage</a:t>
-            </a:r>
-            <a:endParaRPr lang="en-US" sz="1700" dirty="0"/>
-          </a:p>
-        </p:txBody>
-      </p:sp>
-      <p:sp>
-        <p:nvSpPr>
-          <p:cNvPr id="26" name="Text 24"/>
-          <p:cNvSpPr txBox="1"/>
-          <p:nvPr/>
-        </p:nvSpPr>
-        <p:spPr>
-          <a:xfrm>
-            <a:off x="5943600" y="4956048"/>
-            <a:ext cx="2651760" cy="731520"/>
-          </a:xfrm>
-          <a:prstGeom prst="rect">
-            <a:avLst/>
-          </a:prstGeom>
-          <a:noFill/>
-          <a:ln/>
-        </p:spPr>
-        <p:txBody>
-          <a:bodyPr wrap="square" lIns="0" tIns="0" rIns="0" bIns="0" rtlCol="0" anchor="ctr"/>
-          <a:lstStyle/>
-          <a:p>
-            <a:pPr indent="0" marL="0">
-              <a:buNone/>
-            </a:pPr>
-            <a:r>
-              <a:rPr lang="en-US" sz="1400" dirty="0">
-                <a:solidFill>
-                  <a:schemeClr val="tx2"/>
-                </a:solidFill>
-              </a:rPr>
-              <a:t>1 high-noise team</a:t>
-            </a:r>
-            <a:endParaRPr lang="en-US" sz="1400" dirty="0"/>
-          </a:p>
-        </p:txBody>
-      </p:sp>
-      <p:sp>
-        <p:nvSpPr>
-          <p:cNvPr id="27" name="Text 25"/>
-          <p:cNvSpPr txBox="1"/>
-          <p:nvPr/>
-        </p:nvSpPr>
-        <p:spPr>
-          <a:xfrm>
-            <a:off x="8686800" y="4956048"/>
-            <a:ext cx="2926080" cy="731520"/>
-          </a:xfrm>
-          <a:prstGeom prst="rect">
-            <a:avLst/>
-          </a:prstGeom>
-          <a:noFill/>
-          <a:ln/>
-        </p:spPr>
-        <p:txBody>
-          <a:bodyPr wrap="square" lIns="0" tIns="0" rIns="0" bIns="0" rtlCol="0" anchor="ctr"/>
-          <a:lstStyle/>
-          <a:p>
-            <a:pPr indent="0" marL="0">
-              <a:buNone/>
-            </a:pPr>
-            <a:r>
-              <a:rPr lang="en-US" sz="1400" dirty="0">
-                <a:solidFill>
-                  <a:schemeClr val="tx1"/>
-                </a:solidFill>
-              </a:rPr>
-              <a:t>Repeat 'works as designed' reports</a:t>
-            </a:r>
-            <a:endParaRPr lang="en-US" sz="1400" dirty="0"/>
-          </a:p>
-        </p:txBody>
-      </p:sp>
-      <p:sp>
-        <p:nvSpPr>
-          <p:cNvPr id="28" name="Text 26"/>
-          <p:cNvSpPr txBox="1"/>
-          <p:nvPr/>
-        </p:nvSpPr>
-        <p:spPr>
-          <a:xfrm>
-            <a:off x="548640" y="5897880"/>
-            <a:ext cx="11064240" cy="365760"/>
-          </a:xfrm>
-          <a:prstGeom prst="rect">
-            <a:avLst/>
-          </a:prstGeom>
-          <a:noFill/>
-          <a:ln/>
-        </p:spPr>
-        <p:txBody>
-          <a:bodyPr wrap="square" lIns="0" tIns="0" rIns="0" bIns="0" rtlCol="0" anchor="t"/>
-          <a:lstStyle/>
-          <a:p>
-            <a:pPr indent="0" marL="0">
-              <a:buNone/>
-            </a:pPr>
-            <a:r>
-              <a:rPr lang="en-US" sz="1400" dirty="0">
-                <a:solidFill>
-                  <a:schemeClr val="tx2"/>
-                </a:solidFill>
-              </a:rPr>
-              <a:t>1 quarter each, with control teams and a stop rule. A practice spreads only when it beats its control.</a:t>
+              <a:t>bugs are rare per team, so 1 team for 1 quarter cannot show a 30% change for X2-X5 (4 to 33 quarters needed). The new design pools teams and measures events with more volume. Bug counts stay as the slower confirming signal. Each experiment is pre-registered with success and stop rules.</a:t>
             </a:r>
             <a:endParaRPr lang="en-US" sz="1400" dirty="0"/>
           </a:p>

</xml_diff>